<commit_message>
Use the 40-day recorded arrival data throughout
Replace the bundled dataset with the recorded counts (5 Jan - 13 Feb 2026,
three 15-minute slots, weekdays and weekends) and rebuild the paper, the
R Markdown report and the presentation from them.

- Remove the data generator from the app; keep it only as a test fixture
- Regression skips a day type that coincides with whole weekdays
  (Weekend = Saturday + Sunday), avoiding a singular design matrix
- Day picker infers the day type from the data; backtest trains on the
  first half of the record; zero-variance update is explained
- Paper, report and slides rewritten for the new results

Co-Authored-By: Claude Opus 5.5 <noreply@anthropic.com>
Claude-Session: https://claude.ai/code/session_01Ni1aqXZGu1P5U2amwJbPH5
</commit_message>
<xml_diff>
--- a/presentation/canteenflow_presentation.pptx
+++ b/presentation/canteenflow_presentation.pptx
@@ -127,26 +127,26 @@
   <p:extLst>
     <p:ext uri="{521415D9-36F7-43E2-AB2F-B90AF26B5E84}">
       <p14:sectionLst xmlns:p14="http://schemas.microsoft.com/office/powerpoint/2010/main">
-        <p14:section name="Introduction" id="{29440134-1b46-4bfc-6b8a-94a0029de4ba}">
+        <p14:section name="Introduction" id="{5f4dc3a2-fa87-4d38-d905-7751275ee391}">
           <p14:sldIdLst>
             <p14:sldId id="256"/>
             <p14:sldId id="257"/>
             <p14:sldId id="258"/>
           </p14:sldIdLst>
         </p14:section>
-        <p14:section name="Background" id="{a7da6859-cf5f-7013-2edc-fdb01a07211c}">
+        <p14:section name="Background" id="{9ec4493b-db80-947e-4f47-a80b0d8c41e0}">
           <p14:sldIdLst>
             <p14:sldId id="259"/>
             <p14:sldId id="260"/>
           </p14:sldIdLst>
         </p14:section>
-        <p14:section name="Method" id="{de5d66de-fb2d-6439-954c-1a27532f990c}">
+        <p14:section name="Method" id="{0321778d-a4ec-94af-8947-6b83d5d3c4cb}">
           <p14:sldIdLst>
             <p14:sldId id="261"/>
             <p14:sldId id="262"/>
           </p14:sldIdLst>
         </p14:section>
-        <p14:section name="Results" id="{19d492f4-ae04-e5f9-a84d-6ef37e50427e}">
+        <p14:section name="Results" id="{c266e083-f74a-e054-b93a-a1d1f3b994ed}">
           <p14:sldIdLst>
             <p14:sldId id="263"/>
             <p14:sldId id="264"/>
@@ -156,14 +156,14 @@
             <p14:sldId id="268"/>
           </p14:sldIdLst>
         </p14:section>
-        <p14:section name="Prediction" id="{0e0629b6-fd9c-2069-ec24-ef9cb418de62}">
+        <p14:section name="Prediction" id="{81dc9a87-2a2a-b7d3-5ac3-0521ac5ff53c}">
           <p14:sldIdLst>
             <p14:sldId id="269"/>
             <p14:sldId id="270"/>
             <p14:sldId id="271"/>
           </p14:sldIdLst>
         </p14:section>
-        <p14:section name="Comparison and conclusion" id="{f77cedbd-69b0-22c6-718b-df8b1b913c69}">
+        <p14:section name="Comparison and conclusion" id="{a8eaf732-58f2-7d3b-7362-c8c1c0a4d4af}">
           <p14:sldIdLst>
             <p14:sldId id="272"/>
             <p14:sldId id="273"/>
@@ -241,9 +241,9 @@
           </c:dLbls>
           <c:cat>
             <c:multiLvlStrRef>
-              <c:f>Sheet1!$A$2:$A$9</c:f>
+              <c:f>Sheet1!$A$2:$A$4</c:f>
               <c:multiLvlStrCache>
-                <c:ptCount val="8"/>
+                <c:ptCount val="3"/>
                 <c:lvl>
                   <c:pt idx="0">
                     <c:v>12:30</c:v>
@@ -254,54 +254,24 @@
                   <c:pt idx="2">
                     <c:v>13:00</c:v>
                   </c:pt>
-                  <c:pt idx="3">
-                    <c:v>13:15</c:v>
-                  </c:pt>
-                  <c:pt idx="4">
-                    <c:v>13:30</c:v>
-                  </c:pt>
-                  <c:pt idx="5">
-                    <c:v>13:45</c:v>
-                  </c:pt>
-                  <c:pt idx="6">
-                    <c:v>14:00</c:v>
-                  </c:pt>
-                  <c:pt idx="7">
-                    <c:v>14:15</c:v>
-                  </c:pt>
                 </c:lvl>
               </c:multiLvlStrCache>
             </c:multiLvlStrRef>
           </c:cat>
           <c:val>
             <c:numRef>
-              <c:f>Sheet1!$B$2:$B$9</c:f>
+              <c:f>Sheet1!$B$2:$B$4</c:f>
               <c:numCache>
                 <c:formatCode>General</c:formatCode>
-                <c:ptCount val="8"/>
+                <c:ptCount val="3"/>
                 <c:pt idx="0">
-                  <c:v>24.5</c:v>
+                  <c:v>30.5</c:v>
                 </c:pt>
                 <c:pt idx="1">
-                  <c:v>29.4</c:v>
+                  <c:v>31.5</c:v>
                 </c:pt>
                 <c:pt idx="2">
-                  <c:v>33.4</c:v>
-                </c:pt>
-                <c:pt idx="3">
-                  <c:v>34.4</c:v>
-                </c:pt>
-                <c:pt idx="4">
-                  <c:v>29</c:v>
-                </c:pt>
-                <c:pt idx="5">
-                  <c:v>24.7</c:v>
-                </c:pt>
-                <c:pt idx="6">
-                  <c:v>19.1</c:v>
-                </c:pt>
-                <c:pt idx="7">
-                  <c:v>16.3</c:v>
+                  <c:v>27.9</c:v>
                 </c:pt>
               </c:numCache>
             </c:numRef>
@@ -412,9 +382,9 @@
           </c:marker>
           <c:cat>
             <c:multiLvlStrRef>
-              <c:f>Sheet1!$A$2:$A$9</c:f>
+              <c:f>Sheet1!$A$2:$A$4</c:f>
               <c:multiLvlStrCache>
-                <c:ptCount val="8"/>
+                <c:ptCount val="3"/>
                 <c:lvl>
                   <c:pt idx="0">
                     <c:v>12:30</c:v>
@@ -425,31 +395,16 @@
                   <c:pt idx="2">
                     <c:v>13:00</c:v>
                   </c:pt>
-                  <c:pt idx="3">
-                    <c:v>13:15</c:v>
-                  </c:pt>
-                  <c:pt idx="4">
-                    <c:v>13:30</c:v>
-                  </c:pt>
-                  <c:pt idx="5">
-                    <c:v>13:45</c:v>
-                  </c:pt>
-                  <c:pt idx="6">
-                    <c:v>14:00</c:v>
-                  </c:pt>
-                  <c:pt idx="7">
-                    <c:v>14:15</c:v>
-                  </c:pt>
                 </c:lvl>
               </c:multiLvlStrCache>
             </c:multiLvlStrRef>
           </c:cat>
           <c:val>
             <c:numRef>
-              <c:f>Sheet1!$C$2:$C$9</c:f>
+              <c:f>Sheet1!$C$2:$C$4</c:f>
               <c:numCache>
                 <c:formatCode>General</c:formatCode>
-                <c:ptCount val="8"/>
+                <c:ptCount val="3"/>
                 <c:pt idx="0">
                   <c:v>30</c:v>
                 </c:pt>
@@ -457,21 +412,6 @@
                   <c:v>30</c:v>
                 </c:pt>
                 <c:pt idx="2">
-                  <c:v>30</c:v>
-                </c:pt>
-                <c:pt idx="3">
-                  <c:v>30</c:v>
-                </c:pt>
-                <c:pt idx="4">
-                  <c:v>30</c:v>
-                </c:pt>
-                <c:pt idx="5">
-                  <c:v>30</c:v>
-                </c:pt>
-                <c:pt idx="6">
-                  <c:v>30</c:v>
-                </c:pt>
-                <c:pt idx="7">
                   <c:v>30</c:v>
                 </c:pt>
               </c:numCache>
@@ -730,7 +670,7 @@
           </c:tx>
           <c:spPr>
             <a:solidFill>
-              <a:srgbClr val="2E8B57"/>
+              <a:srgbClr val="E07B2E"/>
             </a:solidFill>
             <a:effectLst/>
           </c:spPr>
@@ -765,7 +705,7 @@
             <c:bubble3D val="0"/>
             <c:spPr>
               <a:solidFill>
-                <a:srgbClr val="2E8B57"/>
+                <a:srgbClr val="E07B2E"/>
               </a:solidFill>
               <a:effectLst/>
             </c:spPr>
@@ -776,7 +716,7 @@
             <c:bubble3D val="0"/>
             <c:spPr>
               <a:solidFill>
-                <a:srgbClr val="E07B2E"/>
+                <a:srgbClr val="C0392B"/>
               </a:solidFill>
               <a:effectLst/>
             </c:spPr>
@@ -787,71 +727,16 @@
             <c:bubble3D val="0"/>
             <c:spPr>
               <a:solidFill>
-                <a:srgbClr val="C0392B"/>
-              </a:solidFill>
-              <a:effectLst/>
-            </c:spPr>
-          </c:dPt>
-          <c:dPt>
-            <c:idx val="3"/>
-            <c:invertIfNegative val="0"/>
-            <c:bubble3D val="0"/>
-            <c:spPr>
-              <a:solidFill>
-                <a:srgbClr val="C0392B"/>
-              </a:solidFill>
-              <a:effectLst/>
-            </c:spPr>
-          </c:dPt>
-          <c:dPt>
-            <c:idx val="4"/>
-            <c:invertIfNegative val="0"/>
-            <c:bubble3D val="0"/>
-            <c:spPr>
-              <a:solidFill>
                 <a:srgbClr val="E07B2E"/>
-              </a:solidFill>
-              <a:effectLst/>
-            </c:spPr>
-          </c:dPt>
-          <c:dPt>
-            <c:idx val="5"/>
-            <c:invertIfNegative val="0"/>
-            <c:bubble3D val="0"/>
-            <c:spPr>
-              <a:solidFill>
-                <a:srgbClr val="2E8B57"/>
-              </a:solidFill>
-              <a:effectLst/>
-            </c:spPr>
-          </c:dPt>
-          <c:dPt>
-            <c:idx val="6"/>
-            <c:invertIfNegative val="0"/>
-            <c:bubble3D val="0"/>
-            <c:spPr>
-              <a:solidFill>
-                <a:srgbClr val="2E8B57"/>
-              </a:solidFill>
-              <a:effectLst/>
-            </c:spPr>
-          </c:dPt>
-          <c:dPt>
-            <c:idx val="7"/>
-            <c:invertIfNegative val="0"/>
-            <c:bubble3D val="0"/>
-            <c:spPr>
-              <a:solidFill>
-                <a:srgbClr val="2E8B57"/>
               </a:solidFill>
               <a:effectLst/>
             </c:spPr>
           </c:dPt>
           <c:cat>
             <c:multiLvlStrRef>
-              <c:f>Sheet1!$A$2:$A$9</c:f>
+              <c:f>Sheet1!$A$2:$A$4</c:f>
               <c:multiLvlStrCache>
-                <c:ptCount val="8"/>
+                <c:ptCount val="3"/>
                 <c:lvl>
                   <c:pt idx="0">
                     <c:v>12:30</c:v>
@@ -862,54 +747,24 @@
                   <c:pt idx="2">
                     <c:v>13:00</c:v>
                   </c:pt>
-                  <c:pt idx="3">
-                    <c:v>13:15</c:v>
-                  </c:pt>
-                  <c:pt idx="4">
-                    <c:v>13:30</c:v>
-                  </c:pt>
-                  <c:pt idx="5">
-                    <c:v>13:45</c:v>
-                  </c:pt>
-                  <c:pt idx="6">
-                    <c:v>14:00</c:v>
-                  </c:pt>
-                  <c:pt idx="7">
-                    <c:v>14:15</c:v>
-                  </c:pt>
                 </c:lvl>
               </c:multiLvlStrCache>
             </c:multiLvlStrRef>
           </c:cat>
           <c:val>
             <c:numRef>
-              <c:f>Sheet1!$B$2:$B$9</c:f>
+              <c:f>Sheet1!$B$2:$B$4</c:f>
               <c:numCache>
                 <c:formatCode>General</c:formatCode>
-                <c:ptCount val="8"/>
+                <c:ptCount val="3"/>
                 <c:pt idx="0">
-                  <c:v>11.4</c:v>
+                  <c:v>49</c:v>
                 </c:pt>
                 <c:pt idx="1">
-                  <c:v>41</c:v>
+                  <c:v>55.9</c:v>
                 </c:pt>
                 <c:pt idx="2">
-                  <c:v>68.2</c:v>
-                </c:pt>
-                <c:pt idx="3">
-                  <c:v>73.9</c:v>
-                </c:pt>
-                <c:pt idx="4">
-                  <c:v>38.3</c:v>
-                </c:pt>
-                <c:pt idx="5">
-                  <c:v>12.4</c:v>
-                </c:pt>
-                <c:pt idx="6">
-                  <c:v>0.8</c:v>
-                </c:pt>
-                <c:pt idx="7">
-                  <c:v>0.1</c:v>
+                  <c:v>30.1</c:v>
                 </c:pt>
               </c:numCache>
             </c:numRef>
@@ -1139,7 +994,7 @@
               <c:strCache>
                 <c:ptCount val="1"/>
                 <c:pt idx="0">
-                  <c:v>Change vs Monday regular week, %</c:v>
+                  <c:v>Change vs Monday, %</c:v>
                 </c:pt>
               </c:strCache>
             </c:strRef>
@@ -1203,7 +1058,7 @@
             <c:bubble3D val="0"/>
             <c:spPr>
               <a:solidFill>
-                <a:srgbClr val="00868B"/>
+                <a:srgbClr val="9FD4D6"/>
               </a:solidFill>
               <a:effectLst/>
             </c:spPr>
@@ -1214,7 +1069,7 @@
             <c:bubble3D val="0"/>
             <c:spPr>
               <a:solidFill>
-                <a:srgbClr val="00868B"/>
+                <a:srgbClr val="9FD4D6"/>
               </a:solidFill>
               <a:effectLst/>
             </c:spPr>
@@ -1230,11 +1085,22 @@
               <a:effectLst/>
             </c:spPr>
           </c:dPt>
+          <c:dPt>
+            <c:idx val="5"/>
+            <c:invertIfNegative val="0"/>
+            <c:bubble3D val="0"/>
+            <c:spPr>
+              <a:solidFill>
+                <a:srgbClr val="00868B"/>
+              </a:solidFill>
+              <a:effectLst/>
+            </c:spPr>
+          </c:dPt>
           <c:cat>
             <c:multiLvlStrRef>
-              <c:f>Sheet1!$A$2:$A$6</c:f>
+              <c:f>Sheet1!$A$2:$A$7</c:f>
               <c:multiLvlStrCache>
-                <c:ptCount val="5"/>
+                <c:ptCount val="6"/>
                 <c:lvl>
                   <c:pt idx="0">
                     <c:v>Tuesday</c:v>
@@ -1249,7 +1115,10 @@
                     <c:v>Friday</c:v>
                   </c:pt>
                   <c:pt idx="4">
-                    <c:v>Exam week</c:v>
+                    <c:v>Saturday</c:v>
+                  </c:pt>
+                  <c:pt idx="5">
+                    <c:v>Sunday</c:v>
                   </c:pt>
                 </c:lvl>
               </c:multiLvlStrCache>
@@ -1257,24 +1126,27 @@
           </c:cat>
           <c:val>
             <c:numRef>
-              <c:f>Sheet1!$B$2:$B$6</c:f>
+              <c:f>Sheet1!$B$2:$B$7</c:f>
               <c:numCache>
                 <c:formatCode>General</c:formatCode>
-                <c:ptCount val="5"/>
+                <c:ptCount val="6"/>
                 <c:pt idx="0">
+                  <c:v>-6</c:v>
+                </c:pt>
+                <c:pt idx="1">
+                  <c:v>0.3</c:v>
+                </c:pt>
+                <c:pt idx="2">
                   <c:v>-1.8</c:v>
                 </c:pt>
-                <c:pt idx="1">
-                  <c:v>0</c:v>
-                </c:pt>
-                <c:pt idx="2">
-                  <c:v>-5.4</c:v>
-                </c:pt>
                 <c:pt idx="3">
-                  <c:v>-9.4</c:v>
+                  <c:v>3.9</c:v>
                 </c:pt>
                 <c:pt idx="4">
-                  <c:v>-11.3</c:v>
+                  <c:v>-27.6</c:v>
+                </c:pt>
+                <c:pt idx="5">
+                  <c:v>-25.5</c:v>
                 </c:pt>
               </c:numCache>
             </c:numRef>
@@ -1355,8 +1227,8 @@
         <c:axId val="2094734552"/>
         <c:scaling>
           <c:orientation val="minMax"/>
-          <c:max val="5"/>
-          <c:min val="-15"/>
+          <c:max val="10"/>
+          <c:min val="-35"/>
         </c:scaling>
         <c:delete val="0"/>
         <c:axPos val="b"/>
@@ -1514,9 +1386,9 @@
           </c:dLbls>
           <c:cat>
             <c:multiLvlStrRef>
-              <c:f>Sheet1!$A$2:$A$9</c:f>
+              <c:f>Sheet1!$A$2:$A$4</c:f>
               <c:multiLvlStrCache>
-                <c:ptCount val="8"/>
+                <c:ptCount val="3"/>
                 <c:lvl>
                   <c:pt idx="0">
                     <c:v>12:30</c:v>
@@ -1527,54 +1399,24 @@
                   <c:pt idx="2">
                     <c:v>13:00</c:v>
                   </c:pt>
-                  <c:pt idx="3">
-                    <c:v>13:15</c:v>
-                  </c:pt>
-                  <c:pt idx="4">
-                    <c:v>13:30</c:v>
-                  </c:pt>
-                  <c:pt idx="5">
-                    <c:v>13:45</c:v>
-                  </c:pt>
-                  <c:pt idx="6">
-                    <c:v>14:00</c:v>
-                  </c:pt>
-                  <c:pt idx="7">
-                    <c:v>14:15</c:v>
-                  </c:pt>
                 </c:lvl>
               </c:multiLvlStrCache>
             </c:multiLvlStrRef>
           </c:cat>
           <c:val>
             <c:numRef>
-              <c:f>Sheet1!$B$2:$B$9</c:f>
+              <c:f>Sheet1!$B$2:$B$4</c:f>
               <c:numCache>
                 <c:formatCode>General</c:formatCode>
-                <c:ptCount val="8"/>
+                <c:ptCount val="3"/>
                 <c:pt idx="0">
-                  <c:v>11.4</c:v>
+                  <c:v>49</c:v>
                 </c:pt>
                 <c:pt idx="1">
-                  <c:v>41</c:v>
+                  <c:v>55.9</c:v>
                 </c:pt>
                 <c:pt idx="2">
-                  <c:v>68.2</c:v>
-                </c:pt>
-                <c:pt idx="3">
-                  <c:v>73.9</c:v>
-                </c:pt>
-                <c:pt idx="4">
-                  <c:v>38.3</c:v>
-                </c:pt>
-                <c:pt idx="5">
-                  <c:v>12.4</c:v>
-                </c:pt>
-                <c:pt idx="6">
-                  <c:v>0.8</c:v>
-                </c:pt>
-                <c:pt idx="7">
-                  <c:v>0.1</c:v>
+                  <c:v>30.1</c:v>
                 </c:pt>
               </c:numCache>
             </c:numRef>
@@ -1627,9 +1469,9 @@
           </c:dLbls>
           <c:cat>
             <c:multiLvlStrRef>
-              <c:f>Sheet1!$A$2:$A$9</c:f>
+              <c:f>Sheet1!$A$2:$A$4</c:f>
               <c:multiLvlStrCache>
-                <c:ptCount val="8"/>
+                <c:ptCount val="3"/>
                 <c:lvl>
                   <c:pt idx="0">
                     <c:v>12:30</c:v>
@@ -1640,54 +1482,24 @@
                   <c:pt idx="2">
                     <c:v>13:00</c:v>
                   </c:pt>
-                  <c:pt idx="3">
-                    <c:v>13:15</c:v>
-                  </c:pt>
-                  <c:pt idx="4">
-                    <c:v>13:30</c:v>
-                  </c:pt>
-                  <c:pt idx="5">
-                    <c:v>13:45</c:v>
-                  </c:pt>
-                  <c:pt idx="6">
-                    <c:v>14:00</c:v>
-                  </c:pt>
-                  <c:pt idx="7">
-                    <c:v>14:15</c:v>
-                  </c:pt>
                 </c:lvl>
               </c:multiLvlStrCache>
             </c:multiLvlStrRef>
           </c:cat>
           <c:val>
             <c:numRef>
-              <c:f>Sheet1!$C$2:$C$9</c:f>
+              <c:f>Sheet1!$C$2:$C$4</c:f>
               <c:numCache>
                 <c:formatCode>General</c:formatCode>
-                <c:ptCount val="8"/>
+                <c:ptCount val="3"/>
                 <c:pt idx="0">
-                  <c:v>12.8</c:v>
+                  <c:v>49</c:v>
                 </c:pt>
                 <c:pt idx="1">
-                  <c:v>41.3</c:v>
+                  <c:v>55.9</c:v>
                 </c:pt>
                 <c:pt idx="2">
-                  <c:v>66.5</c:v>
-                </c:pt>
-                <c:pt idx="3">
-                  <c:v>71.8</c:v>
-                </c:pt>
-                <c:pt idx="4">
-                  <c:v>38.8</c:v>
-                </c:pt>
-                <c:pt idx="5">
-                  <c:v>13.9</c:v>
-                </c:pt>
-                <c:pt idx="6">
-                  <c:v>1.1</c:v>
-                </c:pt>
-                <c:pt idx="7">
-                  <c:v>0.1</c:v>
+                  <c:v>30.1</c:v>
                 </c:pt>
               </c:numCache>
             </c:numRef>
@@ -1990,7 +1802,7 @@
             <c:bubble3D val="0"/>
             <c:spPr>
               <a:solidFill>
-                <a:srgbClr val="9FD4D6"/>
+                <a:srgbClr val="1B2A4A"/>
               </a:solidFill>
               <a:effectLst/>
             </c:spPr>
@@ -2006,66 +1818,11 @@
               <a:effectLst/>
             </c:spPr>
           </c:dPt>
-          <c:dPt>
-            <c:idx val="3"/>
-            <c:invertIfNegative val="0"/>
-            <c:bubble3D val="0"/>
-            <c:spPr>
-              <a:solidFill>
-                <a:srgbClr val="1B2A4A"/>
-              </a:solidFill>
-              <a:effectLst/>
-            </c:spPr>
-          </c:dPt>
-          <c:dPt>
-            <c:idx val="4"/>
-            <c:invertIfNegative val="0"/>
-            <c:bubble3D val="0"/>
-            <c:spPr>
-              <a:solidFill>
-                <a:srgbClr val="9FD4D6"/>
-              </a:solidFill>
-              <a:effectLst/>
-            </c:spPr>
-          </c:dPt>
-          <c:dPt>
-            <c:idx val="5"/>
-            <c:invertIfNegative val="0"/>
-            <c:bubble3D val="0"/>
-            <c:spPr>
-              <a:solidFill>
-                <a:srgbClr val="9FD4D6"/>
-              </a:solidFill>
-              <a:effectLst/>
-            </c:spPr>
-          </c:dPt>
-          <c:dPt>
-            <c:idx val="6"/>
-            <c:invertIfNegative val="0"/>
-            <c:bubble3D val="0"/>
-            <c:spPr>
-              <a:solidFill>
-                <a:srgbClr val="9FD4D6"/>
-              </a:solidFill>
-              <a:effectLst/>
-            </c:spPr>
-          </c:dPt>
-          <c:dPt>
-            <c:idx val="7"/>
-            <c:invertIfNegative val="0"/>
-            <c:bubble3D val="0"/>
-            <c:spPr>
-              <a:solidFill>
-                <a:srgbClr val="9FD4D6"/>
-              </a:solidFill>
-              <a:effectLst/>
-            </c:spPr>
-          </c:dPt>
           <c:cat>
             <c:multiLvlStrRef>
-              <c:f>Sheet1!$A$2:$A$9</c:f>
+              <c:f>Sheet1!$A$2:$A$4</c:f>
               <c:multiLvlStrCache>
-                <c:ptCount val="8"/>
+                <c:ptCount val="3"/>
                 <c:lvl>
                   <c:pt idx="0">
                     <c:v>12:30</c:v>
@@ -2076,54 +1833,24 @@
                   <c:pt idx="2">
                     <c:v>13:00</c:v>
                   </c:pt>
-                  <c:pt idx="3">
-                    <c:v>13:15</c:v>
-                  </c:pt>
-                  <c:pt idx="4">
-                    <c:v>13:30</c:v>
-                  </c:pt>
-                  <c:pt idx="5">
-                    <c:v>13:45</c:v>
-                  </c:pt>
-                  <c:pt idx="6">
-                    <c:v>14:00</c:v>
-                  </c:pt>
-                  <c:pt idx="7">
-                    <c:v>14:15</c:v>
-                  </c:pt>
                 </c:lvl>
               </c:multiLvlStrCache>
             </c:multiLvlStrRef>
           </c:cat>
           <c:val>
             <c:numRef>
-              <c:f>Sheet1!$B$2:$B$9</c:f>
+              <c:f>Sheet1!$B$2:$B$4</c:f>
               <c:numCache>
                 <c:formatCode>General</c:formatCode>
-                <c:ptCount val="8"/>
+                <c:ptCount val="3"/>
                 <c:pt idx="0">
-                  <c:v>1.9</c:v>
+                  <c:v>37</c:v>
                 </c:pt>
                 <c:pt idx="1">
-                  <c:v>10.9</c:v>
+                  <c:v>45.6</c:v>
                 </c:pt>
                 <c:pt idx="2">
-                  <c:v>32.8</c:v>
-                </c:pt>
-                <c:pt idx="3">
-                  <c:v>41.9</c:v>
-                </c:pt>
-                <c:pt idx="4">
-                  <c:v>10.6</c:v>
-                </c:pt>
-                <c:pt idx="5">
-                  <c:v>1.9</c:v>
-                </c:pt>
-                <c:pt idx="6">
-                  <c:v>0.1</c:v>
-                </c:pt>
-                <c:pt idx="7">
-                  <c:v>0</c:v>
+                  <c:v>17.4</c:v>
                 </c:pt>
               </c:numCache>
             </c:numRef>
@@ -2391,27 +2118,15 @@
           </c:dLbls>
           <c:cat>
             <c:multiLvlStrRef>
-              <c:f>Sheet1!$A$2:$A$7</c:f>
+              <c:f>Sheet1!$A$2:$A$3</c:f>
               <c:multiLvlStrCache>
-                <c:ptCount val="6"/>
+                <c:ptCount val="2"/>
                 <c:lvl>
                   <c:pt idx="0">
-                    <c:v>13:00</c:v>
+                    <c:v>12:45</c:v>
                   </c:pt>
                   <c:pt idx="1">
-                    <c:v>13:15</c:v>
-                  </c:pt>
-                  <c:pt idx="2">
-                    <c:v>13:30</c:v>
-                  </c:pt>
-                  <c:pt idx="3">
-                    <c:v>13:45</c:v>
-                  </c:pt>
-                  <c:pt idx="4">
-                    <c:v>14:00</c:v>
-                  </c:pt>
-                  <c:pt idx="5">
-                    <c:v>14:15</c:v>
+                    <c:v>13:00</c:v>
                   </c:pt>
                 </c:lvl>
               </c:multiLvlStrCache>
@@ -2419,27 +2134,15 @@
           </c:cat>
           <c:val>
             <c:numRef>
-              <c:f>Sheet1!$B$2:$B$7</c:f>
+              <c:f>Sheet1!$B$2:$B$3</c:f>
               <c:numCache>
                 <c:formatCode>General</c:formatCode>
-                <c:ptCount val="6"/>
+                <c:ptCount val="2"/>
                 <c:pt idx="0">
-                  <c:v>75.9</c:v>
+                  <c:v>72.4</c:v>
                 </c:pt>
                 <c:pt idx="1">
-                  <c:v>80.7</c:v>
-                </c:pt>
-                <c:pt idx="2">
-                  <c:v>49.4</c:v>
-                </c:pt>
-                <c:pt idx="3">
-                  <c:v>19.8</c:v>
-                </c:pt>
-                <c:pt idx="4">
-                  <c:v>1.6</c:v>
-                </c:pt>
-                <c:pt idx="5">
-                  <c:v>0.2</c:v>
+                  <c:v>44.4</c:v>
                 </c:pt>
               </c:numCache>
             </c:numRef>
@@ -2454,7 +2157,7 @@
               <c:strCache>
                 <c:ptCount val="1"/>
                 <c:pt idx="0">
-                  <c:v>After seeing 30 and 36 arrivals</c:v>
+                  <c:v>After a first slot of 38 arrivals</c:v>
                 </c:pt>
               </c:strCache>
             </c:strRef>
@@ -2492,27 +2195,15 @@
           </c:dLbls>
           <c:cat>
             <c:multiLvlStrRef>
-              <c:f>Sheet1!$A$2:$A$7</c:f>
+              <c:f>Sheet1!$A$2:$A$3</c:f>
               <c:multiLvlStrCache>
-                <c:ptCount val="6"/>
+                <c:ptCount val="2"/>
                 <c:lvl>
                   <c:pt idx="0">
-                    <c:v>13:00</c:v>
+                    <c:v>12:45</c:v>
                   </c:pt>
                   <c:pt idx="1">
-                    <c:v>13:15</c:v>
-                  </c:pt>
-                  <c:pt idx="2">
-                    <c:v>13:30</c:v>
-                  </c:pt>
-                  <c:pt idx="3">
-                    <c:v>13:45</c:v>
-                  </c:pt>
-                  <c:pt idx="4">
-                    <c:v>14:00</c:v>
-                  </c:pt>
-                  <c:pt idx="5">
-                    <c:v>14:15</c:v>
+                    <c:v>13:00</c:v>
                   </c:pt>
                 </c:lvl>
               </c:multiLvlStrCache>
@@ -2520,27 +2211,15 @@
           </c:cat>
           <c:val>
             <c:numRef>
-              <c:f>Sheet1!$C$2:$C$7</c:f>
+              <c:f>Sheet1!$C$2:$C$3</c:f>
               <c:numCache>
                 <c:formatCode>General</c:formatCode>
-                <c:ptCount val="6"/>
+                <c:ptCount val="2"/>
                 <c:pt idx="0">
-                  <c:v>82.6</c:v>
+                  <c:v>72.4</c:v>
                 </c:pt>
                 <c:pt idx="1">
-                  <c:v>86.6</c:v>
-                </c:pt>
-                <c:pt idx="2">
-                  <c:v>57.8</c:v>
-                </c:pt>
-                <c:pt idx="3">
-                  <c:v>25.3</c:v>
-                </c:pt>
-                <c:pt idx="4">
-                  <c:v>2.4</c:v>
-                </c:pt>
-                <c:pt idx="5">
-                  <c:v>0.3</c:v>
+                  <c:v>44.4</c:v>
                 </c:pt>
               </c:numCache>
             </c:numRef>
@@ -3252,7 +2931,7 @@
           <a:p>
             <a:r>
               <a:rPr lang="en-US" dirty="0"/>
-              <a:t>P(X &gt; C) = 1 − P(X ≤ C) with λ̂ from each slot. Across the confidence interval for λ, the peak slot's risk ranges from about 67% to 80%.</a:t>
+              <a:t>P(X &gt; C) = 1 − P(X ≤ C) with λ̂ from each slot. Across the confidence interval for λ, the peak slot's risk ranges from about 44% to 68%. No slot is low risk.</a:t>
             </a:r>
             <a:endParaRPr lang="en-US" dirty="0"/>
           </a:p>
@@ -3340,7 +3019,7 @@
           <a:p>
             <a:r>
               <a:rPr lang="en-US" dirty="0"/>
-              <a:t>Students who can choose should eat after 14:15: only about 0.08% chance of overload, against 74% at the peak.</a:t>
+              <a:t>Students who can choose should come at 13:00 or later: about 30% chance of overload, against 56% at 12:45–13:00.</a:t>
             </a:r>
             <a:endParaRPr lang="en-US" dirty="0"/>
           </a:p>
@@ -3428,7 +3107,7 @@
           <a:p>
             <a:r>
               <a:rPr lang="en-US" dirty="0"/>
-              <a:t>Multiple linear regression with dummy variables. Friday is about 9% quieter and exam weeks about 11% quieter. These effects drive the day-specific forecasts.</a:t>
+              <a:t>Multiple linear regression with dummy variables. Saturday is about 28% and Sunday about 25% quieter than Monday; the weekdays do not differ significantly. The 13:00 slot is about 9% quieter than 12:30. These effects drive the day-specific forecasts.</a:t>
             </a:r>
             <a:endParaRPr lang="en-US" dirty="0"/>
           </a:p>
@@ -3516,7 +3195,7 @@
           <a:p>
             <a:r>
               <a:rPr lang="en-US" dirty="0"/>
-              <a:t>Per-slot tests pass, but pooling across slots reveals mild overdispersion. The negative binomial (Poisson–Gamma) model handles it and is used for forecasts.</a:t>
+              <a:t>Once slot and day-of-week effects are removed, the Pearson test finds no overdispersion, so the negative binomial (Poisson–Gamma) model collapses to the plain Poisson model.</a:t>
             </a:r>
             <a:endParaRPr lang="en-US" dirty="0"/>
           </a:p>
@@ -3692,7 +3371,7 @@
           <a:p>
             <a:r>
               <a:rPr lang="en-US" dirty="0"/>
-              <a:t>This is the practical use: by 13:00 the canteen manager can see whether today is running hot and open an extra counter before the peak.</a:t>
+              <a:t>A useful negative result: at this canteen whole days do not run hot or cold beyond the day-of-week pattern, so the early count does not change the forecast. The method is ready for canteens where days do vary.</a:t>
             </a:r>
             <a:endParaRPr lang="en-US" dirty="0"/>
           </a:p>
@@ -3956,7 +3635,7 @@
           <a:p>
             <a:r>
               <a:rPr lang="en-US" dirty="0"/>
-              <a:t>Live demo if time permits: change the day, toggle exam week, change capacity, and show the same-day update.</a:t>
+              <a:t>Live demo if time permits: change the day, change capacity, and show the forecast check.</a:t>
             </a:r>
             <a:endParaRPr lang="en-US" dirty="0"/>
           </a:p>
@@ -4044,7 +3723,7 @@
           <a:p>
             <a:r>
               <a:rPr lang="en-US" dirty="0"/>
-              <a:t>Close with the practical message: avoid 13:00–13:30, open an extra counter when the early counts run high, and collect real counts to confirm.</a:t>
+              <a:t>Close with the practical message: avoid 12:45–13:00, come at 13:00 or later if possible, and plan for about 36 servings per 15 minutes on weekdays.</a:t>
             </a:r>
             <a:endParaRPr lang="en-US" dirty="0"/>
           </a:p>
@@ -4572,7 +4251,7 @@
           <a:p>
             <a:r>
               <a:rPr lang="en-US" dirty="0"/>
-              <a:t>Field collection is in progress. All methods re-estimate everything from the counts, so they apply unchanged when the real counts replace the synthetic file.</a:t>
+              <a:t>Forty consecutive days of counts, including ten weekend days. Every rate, test and forecast in the following slides is estimated from these counts alone.</a:t>
             </a:r>
             <a:endParaRPr lang="en-US" dirty="0"/>
           </a:p>
@@ -4836,7 +4515,7 @@
           <a:p>
             <a:r>
               <a:rPr lang="en-US" dirty="0"/>
-              <a:t>Each bar is the sample mean of 90 days for that slot. The exact confidence intervals are narrow (about ±1.2), so the peak is well determined.</a:t>
+              <a:t>Each bar is the sample mean of 40 days for that slot. The exact confidence intervals are about ±1.7, so the first two slots sit right at the capacity line.</a:t>
             </a:r>
             <a:endParaRPr lang="en-US" dirty="0"/>
           </a:p>
@@ -4924,7 +4603,7 @@
           <a:p>
             <a:r>
               <a:rPr lang="en-US" dirty="0"/>
-              <a:t>Chi-square goodness-of-fit test per slot, plus the index-of-dispersion test. A binomial check guards against multiple testing: with 8 tests, about 0.4 rejections are expected by chance.</a:t>
+              <a:t>Chi-square goodness-of-fit test per slot, plus the index-of-dispersion test. A binomial check guards against multiple testing: with 3 tests, about 0.15 rejections are expected by chance.</a:t>
             </a:r>
             <a:endParaRPr lang="en-US" dirty="0"/>
           </a:p>
@@ -6103,7 +5782,7 @@
                 <a:ea typeface="Cambria" pitchFamily="34" charset="-122"/>
                 <a:cs typeface="Cambria" pitchFamily="34" charset="-120"/>
               </a:rPr>
-              <a:t>Overload risk: two slots are high risk</a:t>
+              <a:t>Overload risk: 12:45–13:00 is high risk</a:t>
             </a:r>
             <a:endParaRPr lang="en-US" sz="2800" dirty="0"/>
           </a:p>
@@ -6180,7 +5859,7 @@
                 <a:ea typeface="Cambria" pitchFamily="34" charset="-122"/>
                 <a:cs typeface="Cambria" pitchFamily="34" charset="-120"/>
               </a:rPr>
-              <a:t>73.9%</a:t>
+              <a:t>55.9%</a:t>
             </a:r>
             <a:endParaRPr lang="en-US" sz="3200" dirty="0"/>
           </a:p>
@@ -6216,7 +5895,7 @@
                   <a:schemeClr val="tx1"/>
                 </a:solidFill>
               </a:rPr>
-              <a:t>chance of overload at 13:15–13:30</a:t>
+              <a:t>chance of overload at 12:45–13:00</a:t>
             </a:r>
             <a:endParaRPr lang="en-US" sz="1200" dirty="0"/>
           </a:p>
@@ -6255,7 +5934,7 @@
                 <a:ea typeface="Cambria" pitchFamily="34" charset="-122"/>
                 <a:cs typeface="Cambria" pitchFamily="34" charset="-120"/>
               </a:rPr>
-              <a:t>39</a:t>
+              <a:t>36</a:t>
             </a:r>
             <a:endParaRPr lang="en-US" sz="3200" dirty="0"/>
           </a:p>
@@ -6338,6 +6017,28 @@
                   <a:schemeClr val="tx1"/>
                 </a:solidFill>
               </a:rPr>
+              <a:t>1   </a:t>
+            </a:r>
+            <a:pPr indent="0" marL="0">
+              <a:buNone/>
+            </a:pPr>
+            <a:r>
+              <a:rPr lang="en-US" sz="1400" b="1" dirty="0">
+                <a:solidFill>
+                  <a:schemeClr val="accent4"/>
+                </a:solidFill>
+              </a:rPr>
+              <a:t>Medium </a:t>
+            </a:r>
+            <a:pPr indent="0" marL="0">
+              <a:buNone/>
+            </a:pPr>
+            <a:r>
+              <a:rPr lang="en-US" sz="1400" dirty="0">
+                <a:solidFill>
+                  <a:schemeClr val="tx1"/>
+                </a:solidFill>
+              </a:rPr>
               <a:t>2   </a:t>
             </a:r>
             <a:pPr indent="0" marL="0">
@@ -6346,10 +6047,10 @@
             <a:r>
               <a:rPr lang="en-US" sz="1400" b="1" dirty="0">
                 <a:solidFill>
-                  <a:schemeClr val="accent4"/>
-                </a:solidFill>
-              </a:rPr>
-              <a:t>Medium </a:t>
+                  <a:schemeClr val="accent5"/>
+                </a:solidFill>
+              </a:rPr>
+              <a:t>Low </a:t>
             </a:r>
             <a:pPr indent="0" marL="0">
               <a:buNone/>
@@ -6360,29 +6061,7 @@
                   <a:schemeClr val="tx1"/>
                 </a:solidFill>
               </a:rPr>
-              <a:t>2   </a:t>
-            </a:r>
-            <a:pPr indent="0" marL="0">
-              <a:buNone/>
-            </a:pPr>
-            <a:r>
-              <a:rPr lang="en-US" sz="1400" b="1" dirty="0">
-                <a:solidFill>
-                  <a:schemeClr val="accent5"/>
-                </a:solidFill>
-              </a:rPr>
-              <a:t>Low </a:t>
-            </a:r>
-            <a:pPr indent="0" marL="0">
-              <a:buNone/>
-            </a:pPr>
-            <a:r>
-              <a:rPr lang="en-US" sz="1400" dirty="0">
-                <a:solidFill>
-                  <a:schemeClr val="tx1"/>
-                </a:solidFill>
-              </a:rPr>
-              <a:t>4</a:t>
+              <a:t>0</a:t>
             </a:r>
             <a:endParaRPr lang="en-US" sz="1400" dirty="0"/>
           </a:p>
@@ -6554,7 +6233,7 @@
                 <a:ea typeface="Cambria" pitchFamily="34" charset="-122"/>
                 <a:cs typeface="Cambria" pitchFamily="34" charset="-120"/>
               </a:rPr>
-              <a:t>16.3</a:t>
+              <a:t>27.9</a:t>
             </a:r>
             <a:endParaRPr lang="en-US" sz="3200" dirty="0"/>
           </a:p>
@@ -6590,7 +6269,7 @@
                   <a:schemeClr val="tx1"/>
                 </a:solidFill>
               </a:rPr>
-              <a:t>students on average at 14:15–14:30 (quietest)</a:t>
+              <a:t>students on average at 13:00–13:15 (quietest)</a:t>
             </a:r>
             <a:endParaRPr lang="en-US" sz="1200" dirty="0"/>
           </a:p>
@@ -6651,7 +6330,7 @@
                 <a:ea typeface="Cambria" pitchFamily="34" charset="-122"/>
                 <a:cs typeface="Cambria" pitchFamily="34" charset="-120"/>
               </a:rPr>
-              <a:t>19.1</a:t>
+              <a:t>30.5</a:t>
             </a:r>
             <a:endParaRPr lang="en-US" sz="3200" dirty="0"/>
           </a:p>
@@ -6687,7 +6366,7 @@
                   <a:schemeClr val="tx1"/>
                 </a:solidFill>
               </a:rPr>
-              <a:t>at 14:00–14:15 (next quietest)</a:t>
+              <a:t>at 12:30–12:45 (next quietest)</a:t>
             </a:r>
             <a:endParaRPr lang="en-US" sz="1200" dirty="0"/>
           </a:p>
@@ -6748,7 +6427,7 @@
                 <a:ea typeface="Cambria" pitchFamily="34" charset="-122"/>
                 <a:cs typeface="Cambria" pitchFamily="34" charset="-120"/>
               </a:rPr>
-              <a:t>p = 5.2 × 10⁻⁶</a:t>
+              <a:t>p = 0.015</a:t>
             </a:r>
             <a:endParaRPr lang="en-US" sz="2600" dirty="0"/>
           </a:p>
@@ -6942,7 +6621,7 @@
                 <a:ea typeface="Cambria" pitchFamily="34" charset="-122"/>
                 <a:cs typeface="Cambria" pitchFamily="34" charset="-120"/>
               </a:rPr>
-              <a:t>Weekday and exam weeks shift the whole day</a:t>
+              <a:t>Weekends cut lunch arrivals by about a quarter</a:t>
             </a:r>
             <a:endParaRPr lang="en-US" sz="2800" dirty="0"/>
           </a:p>
@@ -7019,7 +6698,7 @@
                 <a:ea typeface="Cambria" pitchFamily="34" charset="-122"/>
                 <a:cs typeface="Cambria" pitchFamily="34" charset="-120"/>
               </a:rPr>
-              <a:t>R² = 0.58</a:t>
+              <a:t>R² = 0.55</a:t>
             </a:r>
             <a:endParaRPr lang="en-US" sz="3200" dirty="0"/>
           </a:p>
@@ -7063,7 +6742,7 @@
       </p:sp>
       <p:sp>
         <p:nvSpPr>
-          <p:cNvPr id="7" name="exam effect value"/>
+          <p:cNvPr id="7" name="weekend effect value"/>
           <p:cNvSpPr txBox="1"/>
           <p:nvPr/>
         </p:nvSpPr>
@@ -7094,7 +6773,7 @@
                 <a:ea typeface="Cambria" pitchFamily="34" charset="-122"/>
                 <a:cs typeface="Cambria" pitchFamily="34" charset="-120"/>
               </a:rPr>
-              <a:t>−11.3%</a:t>
+              <a:t>71 vs 96</a:t>
             </a:r>
             <a:endParaRPr lang="en-US" sz="3200" dirty="0"/>
           </a:p>
@@ -7102,7 +6781,7 @@
       </p:sp>
       <p:sp>
         <p:nvSpPr>
-          <p:cNvPr id="8" name="exam effect label"/>
+          <p:cNvPr id="8" name="weekend effect label"/>
           <p:cNvSpPr txBox="1"/>
           <p:nvPr/>
         </p:nvSpPr>
@@ -7130,7 +6809,7 @@
                   <a:schemeClr val="tx1"/>
                 </a:solidFill>
               </a:rPr>
-              <a:t>exam weeks (Welch t-test p = 0.0005)</a:t>
+              <a:t>arrivals per lunch, weekend vs weekday (Welch t-test p &lt; 0.001)</a:t>
             </a:r>
             <a:endParaRPr lang="en-US" sz="1200" dirty="0"/>
           </a:p>
@@ -7166,7 +6845,7 @@
                   <a:schemeClr val="tx1"/>
                 </a:solidFill>
               </a:rPr>
-              <a:t>Dark bars: p &lt; 0.05. Weekday differences in daily totals: ANOVA p = 0.091.</a:t>
+              <a:t>Dark bars: p &lt; 0.05. Monday to Friday do not differ (ANOVA p = 0.37).</a:t>
             </a:r>
             <a:endParaRPr lang="en-US" sz="1100" dirty="0"/>
           </a:p>
@@ -7277,7 +6956,7 @@
                 <a:ea typeface="Cambria" pitchFamily="34" charset="-122"/>
                 <a:cs typeface="Cambria" pitchFamily="34" charset="-120"/>
               </a:rPr>
-              <a:t>Whole days vary a little more than Poisson allows</a:t>
+              <a:t>Whole days vary no more than Poisson allows</a:t>
             </a:r>
             <a:endParaRPr lang="en-US" sz="2800" dirty="0"/>
           </a:p>
@@ -7323,7 +7002,7 @@
       </p:sp>
       <p:sp>
         <p:nvSpPr>
-          <p:cNvPr id="5" name="pearson value"/>
+          <p:cNvPr id="5" name="v hat value"/>
           <p:cNvSpPr txBox="1"/>
           <p:nvPr/>
         </p:nvSpPr>
@@ -7348,13 +7027,13 @@
             <a:r>
               <a:rPr lang="en-US" sz="3200" b="1" dirty="0">
                 <a:solidFill>
-                  <a:schemeClr val="accent3"/>
+                  <a:schemeClr val="accent1"/>
                 </a:solidFill>
                 <a:latin typeface="Cambria" pitchFamily="34" charset="0"/>
                 <a:ea typeface="Cambria" pitchFamily="34" charset="-122"/>
                 <a:cs typeface="Cambria" pitchFamily="34" charset="-120"/>
               </a:rPr>
-              <a:t>p = 0.003</a:t>
+              <a:t>v̂ = 0</a:t>
             </a:r>
             <a:endParaRPr lang="en-US" sz="3200" dirty="0"/>
           </a:p>
@@ -7362,7 +7041,7 @@
       </p:sp>
       <p:sp>
         <p:nvSpPr>
-          <p:cNvPr id="6" name="pearson label"/>
+          <p:cNvPr id="6" name="v hat label"/>
           <p:cNvSpPr txBox="1"/>
           <p:nvPr/>
         </p:nvSpPr>
@@ -7390,7 +7069,7 @@
                   <a:schemeClr val="tx1"/>
                 </a:solidFill>
               </a:rPr>
-              <a:t>Pearson χ² = 812 on 704 df: day-to-day variation exists</a:t>
+              <a:t>no extra day-to-day variation (Pearson χ² = 59.7 on 111 df)</a:t>
             </a:r>
             <a:endParaRPr lang="en-US" sz="1200" dirty="0"/>
           </a:p>
@@ -7398,7 +7077,7 @@
       </p:sp>
       <p:sp>
         <p:nvSpPr>
-          <p:cNvPr id="7" name="v hat value"/>
+          <p:cNvPr id="7" name="ratio value"/>
           <p:cNvSpPr txBox="1"/>
           <p:nvPr/>
         </p:nvSpPr>
@@ -7429,7 +7108,7 @@
                 <a:ea typeface="Cambria" pitchFamily="34" charset="-122"/>
                 <a:cs typeface="Cambria" pitchFamily="34" charset="-120"/>
               </a:rPr>
-              <a:t>v̂ = 0.006</a:t>
+              <a:t>0.54</a:t>
             </a:r>
             <a:endParaRPr lang="en-US" sz="3200" dirty="0"/>
           </a:p>
@@ -7437,7 +7116,7 @@
       </p:sp>
       <p:sp>
         <p:nvSpPr>
-          <p:cNvPr id="8" name="v hat label"/>
+          <p:cNvPr id="8" name="ratio label"/>
           <p:cNvSpPr txBox="1"/>
           <p:nvPr/>
         </p:nvSpPr>
@@ -7465,7 +7144,7 @@
                   <a:schemeClr val="tx1"/>
                 </a:solidFill>
               </a:rPr>
-              <a:t>variance of the busyness factor W (about 7.6% CV)</a:t>
+              <a:t>dispersion ratio: counts vary, if anything, less than Poisson</a:t>
             </a:r>
             <a:endParaRPr lang="en-US" sz="1200" dirty="0"/>
           </a:p>
@@ -7501,7 +7180,7 @@
                   <a:schemeClr val="tx1"/>
                 </a:solidFill>
               </a:rPr>
-              <a:t>Small in practice: overload probabilities change by at most about 2 points.</a:t>
+              <a:t>So the Poisson–Gamma model reduces to Poisson: the two sets of bars are identical.</a:t>
             </a:r>
             <a:endParaRPr lang="en-US" sz="1100" dirty="0"/>
           </a:p>
@@ -7689,7 +7368,7 @@
                 <a:ea typeface="Cambria" pitchFamily="34" charset="-122"/>
                 <a:cs typeface="Cambria" pitchFamily="34" charset="-120"/>
               </a:rPr>
-              <a:t>42%</a:t>
+              <a:t>46%</a:t>
             </a:r>
             <a:endParaRPr lang="en-US" sz="3200" dirty="0"/>
           </a:p>
@@ -7725,7 +7404,7 @@
                   <a:schemeClr val="tx1"/>
                 </a:solidFill>
               </a:rPr>
-              <a:t>peak at 13:15–13:30 (most likely slot)</a:t>
+              <a:t>peak at 12:45–13:00 (most likely slot)</a:t>
             </a:r>
             <a:endParaRPr lang="en-US" sz="1200" dirty="0"/>
           </a:p>
@@ -7764,7 +7443,7 @@
                 <a:ea typeface="Cambria" pitchFamily="34" charset="-122"/>
                 <a:cs typeface="Cambria" pitchFamily="34" charset="-120"/>
               </a:rPr>
-              <a:t>75%</a:t>
+              <a:t>83%</a:t>
             </a:r>
             <a:endParaRPr lang="en-US" sz="3200" dirty="0"/>
           </a:p>
@@ -7800,7 +7479,7 @@
                   <a:schemeClr val="tx1"/>
                 </a:solidFill>
               </a:rPr>
-              <a:t>peak falls in 13:00–13:30</a:t>
+              <a:t>peak falls in 12:30–13:00</a:t>
             </a:r>
             <a:endParaRPr lang="en-US" sz="1200" dirty="0"/>
           </a:p>
@@ -7839,7 +7518,7 @@
                 <a:ea typeface="Cambria" pitchFamily="34" charset="-122"/>
                 <a:cs typeface="Cambria" pitchFamily="34" charset="-120"/>
               </a:rPr>
-              <a:t>98%</a:t>
+              <a:t>95%</a:t>
             </a:r>
             <a:endParaRPr lang="en-US" sz="3200" dirty="0"/>
           </a:p>
@@ -7986,7 +7665,7 @@
                 <a:ea typeface="Cambria" pitchFamily="34" charset="-122"/>
                 <a:cs typeface="Cambria" pitchFamily="34" charset="-120"/>
               </a:rPr>
-              <a:t>Updating the forecast from the first counts</a:t>
+              <a:t>A busy first slot does not predict a busy lunch</a:t>
             </a:r>
             <a:endParaRPr lang="en-US" sz="2800" dirty="0"/>
           </a:p>
@@ -8077,7 +7756,7 @@
                   <a:schemeClr val="tx1"/>
                 </a:solidFill>
               </a:rPr>
-              <a:t>Prior W ~ Gamma(a, a). After the first two slots the posterior is Gamma(a + Σx, a + Σλ).</a:t>
+              <a:t>Prior W ~ Gamma(a, a). After the first slot the posterior is Gamma(a + Σx, a + Σλ).</a:t>
             </a:r>
             <a:endParaRPr lang="en-US" sz="1200" dirty="0"/>
           </a:p>
@@ -8094,7 +7773,7 @@
                   <a:schemeClr val="tx1"/>
                 </a:solidFill>
               </a:rPr>
-              <a:t>A busy morning (30 and 36 vs 26 and 31 forecast) lifts the 13:15 risk from 81% to 87%.</a:t>
+              <a:t>Here v̂ = 0, so the prior sits at 1: a first slot 15% above forecast leaves later risks unchanged.</a:t>
             </a:r>
             <a:endParaRPr lang="en-US" sz="1200" dirty="0"/>
           </a:p>
@@ -8108,7 +7787,7 @@
                   <a:schemeClr val="tx1"/>
                 </a:solidFill>
               </a:rPr>
-              <a:t>On unseen days the update improved the Brier score of later slots: 0.124 → 0.119.</a:t>
+              <a:t>On unseen days the Brier score is the same with and without the update (0.181).</a:t>
             </a:r>
             <a:endParaRPr lang="en-US" sz="1200" dirty="0"/>
           </a:p>
@@ -8219,7 +7898,7 @@
                 <a:ea typeface="Cambria" pitchFamily="34" charset="-122"/>
                 <a:cs typeface="Cambria" pitchFamily="34" charset="-120"/>
               </a:rPr>
-              <a:t>Testing the forecasts on 60 unseen days</a:t>
+              <a:t>Testing the forecasts on 20 unseen days</a:t>
             </a:r>
             <a:endParaRPr lang="en-US" sz="2800" dirty="0"/>
           </a:p>
@@ -8280,7 +7959,7 @@
                 <a:ea typeface="Cambria" pitchFamily="34" charset="-122"/>
                 <a:cs typeface="Cambria" pitchFamily="34" charset="-120"/>
               </a:rPr>
-              <a:t>93.7%</a:t>
+              <a:t>100%</a:t>
             </a:r>
             <a:endParaRPr lang="en-US" sz="2400" dirty="0"/>
           </a:p>
@@ -8316,7 +7995,7 @@
                   <a:schemeClr val="tx1"/>
                 </a:solidFill>
               </a:rPr>
-              <a:t>95% intervals covered the actual count (z-test p = 0.20: consistent with 95%)</a:t>
+              <a:t>95% intervals covered the actual count (z-test p = 0.08: consistent with 95%)</a:t>
             </a:r>
             <a:endParaRPr lang="en-US" sz="1100" dirty="0"/>
           </a:p>
@@ -8413,7 +8092,7 @@
                 <a:ea typeface="Cambria" pitchFamily="34" charset="-122"/>
                 <a:cs typeface="Cambria" pitchFamily="34" charset="-120"/>
               </a:rPr>
-              <a:t>40%</a:t>
+              <a:t>60%</a:t>
             </a:r>
             <a:endParaRPr lang="en-US" sz="2400" dirty="0"/>
           </a:p>
@@ -8449,7 +8128,7 @@
                   <a:schemeClr val="tx1"/>
                 </a:solidFill>
               </a:rPr>
-              <a:t>busiest slot named correctly, vs 13% by chance (p &lt; 0.001)</a:t>
+              <a:t>busiest slot named correctly, vs 40% by chance (p = 0.034)</a:t>
             </a:r>
             <a:endParaRPr lang="en-US" sz="1100" dirty="0"/>
           </a:p>
@@ -8546,7 +8225,7 @@
                 <a:ea typeface="Cambria" pitchFamily="34" charset="-122"/>
                 <a:cs typeface="Cambria" pitchFamily="34" charset="-120"/>
               </a:rPr>
-              <a:t>4.57 vs 4.62</a:t>
+              <a:t>3.93 vs 4.44</a:t>
             </a:r>
             <a:endParaRPr lang="en-US" sz="2400" dirty="0"/>
           </a:p>
@@ -8582,7 +8261,7 @@
                   <a:schemeClr val="tx1"/>
                 </a:solidFill>
               </a:rPr>
-              <a:t>mean absolute error, model vs per-slot average (paired t p = 0.29)</a:t>
+              <a:t>mean absolute error, model vs per-slot average (paired t p = 0.11)</a:t>
             </a:r>
             <a:endParaRPr lang="en-US" sz="1100" dirty="0"/>
           </a:p>
@@ -8679,7 +8358,7 @@
                 <a:ea typeface="Cambria" pitchFamily="34" charset="-122"/>
                 <a:cs typeface="Cambria" pitchFamily="34" charset="-120"/>
               </a:rPr>
-              <a:t>r = 0.73</a:t>
+              <a:t>+31%</a:t>
             </a:r>
             <a:endParaRPr lang="en-US" sz="2400" dirty="0"/>
           </a:p>
@@ -8715,7 +8394,7 @@
                   <a:schemeClr val="tx1"/>
                 </a:solidFill>
               </a:rPr>
-              <a:t>correlation between predicted and actual counts (p &lt; 0.001)</a:t>
+              <a:t>Brier skill of overload forecasts over the per-slot average (0.172 vs 0.248)</a:t>
             </a:r>
             <a:endParaRPr lang="en-US" sz="1100" dirty="0"/>
           </a:p>
@@ -8798,7 +8477,7 @@
                   <a:schemeClr val="tx1"/>
                 </a:solidFill>
               </a:rPr>
-              <a:t>Every day is forecast only from earlier days (477 slot forecasts). Intervals and peak-slot prediction work; the gain in point accuracy over a simple average is small and not significant, which is expected when day effects are mild. Exam days benefit most (MAE 4.53 vs 4.78).</a:t>
+              <a:t>The first 20 days train the model; each later day is forecast only from earlier days (60 slot forecasts). Peak-slot prediction and overload probabilities beat the average; the gain in point accuracy is not significant over 20 days. Weekends benefit most (MAE 3.26 vs 4.81).</a:t>
             </a:r>
             <a:endParaRPr lang="en-US" sz="1400" dirty="0"/>
           </a:p>
@@ -10841,7 +10520,7 @@
                   <a:schemeClr val="tx1"/>
                 </a:solidFill>
               </a:rPr>
-              <a:t>Within the project: the regression + Poisson–Gamma forecast versus the per-slot average gives better-calibrated intervals and a big gain in peak-slot hits, but similar point error.</a:t>
+              <a:t>Within the project: the day-of-week forecast versus the per-slot average gives a 31% Brier skill and lower error on weekends, but no significant gain in overall point error.</a:t>
             </a:r>
             <a:endParaRPr lang="en-US" sz="1200" dirty="0"/>
           </a:p>
@@ -11036,7 +10715,7 @@
                   <a:schemeClr val="tx1"/>
                 </a:solidFill>
               </a:rPr>
-              <a:t>When to go: plain-language advice for any weekday or exam week</a:t>
+              <a:t>When to go: plain-language advice for any day of the week</a:t>
             </a:r>
             <a:endParaRPr lang="en-US" sz="1200" dirty="0"/>
           </a:p>
@@ -11108,7 +10787,7 @@
                   <a:schemeClr val="accent1"/>
                 </a:solidFill>
               </a:rPr>
-              <a:t>Python · Streamlit · Plotly 3D · SciPy · 83 automated tests. Upload real counts and every result updates.</a:t>
+              <a:t>Python · Streamlit · Plotly 3D · SciPy · 72 automated tests. Upload real counts and every result updates.</a:t>
             </a:r>
             <a:endParaRPr lang="en-US" sz="1300" dirty="0"/>
           </a:p>
@@ -11316,7 +10995,7 @@
                   <a:schemeClr val="tx1"/>
                 </a:solidFill>
               </a:rPr>
-              <a:t>Highest risk at 13:15–13:30 (74%); 13:00–13:30 is the danger window.</a:t>
+              <a:t>Highest risk at 12:45–13:00 (56%); no slot is low risk.</a:t>
             </a:r>
             <a:endParaRPr lang="en-US" sz="1400" dirty="0"/>
           </a:p>
@@ -11334,7 +11013,7 @@
                   <a:schemeClr val="tx1"/>
                 </a:solidFill>
               </a:rPr>
-              <a:t>14:15–14:30 is significantly quieter (p = 5.2 × 10⁻⁶).</a:t>
+              <a:t>13:00–13:15 is significantly quieter (p = 0.015).</a:t>
             </a:r>
             <a:endParaRPr lang="en-US" sz="1400" dirty="0"/>
           </a:p>
@@ -11352,7 +11031,7 @@
                   <a:schemeClr val="tx1"/>
                 </a:solidFill>
               </a:rPr>
-              <a:t>39 per slot keeps every slot below 20% risk.</a:t>
+              <a:t>36 per slot keeps every slot below 20% risk; weekends are about 26% quieter.</a:t>
             </a:r>
             <a:endParaRPr lang="en-US" sz="1400" dirty="0"/>
           </a:p>
@@ -11370,7 +11049,7 @@
                   <a:schemeClr val="tx1"/>
                 </a:solidFill>
               </a:rPr>
-              <a:t>The peak time is predictable (40% hits vs 13% chance) and early counts sharpen it.</a:t>
+              <a:t>The peak time is predictable (60% hits vs 40% chance) with a 31% Brier skill.</a:t>
             </a:r>
             <a:endParaRPr lang="en-US" sz="1400" dirty="0"/>
           </a:p>
@@ -11423,7 +11102,7 @@
                   <a:schemeClr val="tx1"/>
                 </a:solidFill>
               </a:rPr>
-              <a:t>Synthetic data for now; arrival risk, not waiting time; group arrivals ignored.</a:t>
+              <a:t>40 days and the first 45 minutes of lunch only; arrival risk, not waiting time; group arrivals ignored.</a:t>
             </a:r>
             <a:endParaRPr lang="en-US" sz="1400" dirty="0"/>
           </a:p>
@@ -11452,7 +11131,7 @@
                   <a:schemeClr val="tx1"/>
                 </a:solidFill>
               </a:rPr>
-              <a:t>Replace with field counts</a:t>
+              <a:t>Count the whole lunch period over a full semester</a:t>
             </a:r>
             <a:endParaRPr lang="en-US" sz="1400" dirty="0"/>
           </a:p>
@@ -11482,7 +11161,7 @@
                   <a:schemeClr val="tx1"/>
                 </a:solidFill>
               </a:rPr>
-              <a:t>Automatic same-day update from turnstile or camera counts</a:t>
+              <a:t>Automate counting with turnstile or camera data</a:t>
             </a:r>
             <a:endParaRPr lang="en-US" sz="1400" dirty="0"/>
           </a:p>
@@ -11738,7 +11417,7 @@
                 <a:ea typeface="Cambria" pitchFamily="34" charset="-122"/>
                 <a:cs typeface="Cambria" pitchFamily="34" charset="-120"/>
               </a:rPr>
-              <a:t>8 slots</a:t>
+              <a:t>3 slots</a:t>
             </a:r>
             <a:endParaRPr lang="en-US" sz="3200" dirty="0"/>
           </a:p>
@@ -11774,7 +11453,7 @@
                   <a:schemeClr val="tx1"/>
                 </a:solidFill>
               </a:rPr>
-              <a:t>15-minute slots from 12:30 to 14:30</a:t>
+              <a:t>15-minute slots from 12:30 to 13:15, the start of lunch</a:t>
             </a:r>
             <a:endParaRPr lang="en-US" sz="1200" dirty="0"/>
           </a:p>
@@ -12741,7 +12420,7 @@
                   <a:schemeClr val="tx1"/>
                 </a:solidFill>
               </a:rPr>
-              <a:t>Arrival counts in fixed 15-minute slots across working days</a:t>
+              <a:t>Arrival counts in fixed 15-minute slots over 40 days</a:t>
             </a:r>
             <a:endParaRPr lang="en-US" sz="1100" dirty="0"/>
           </a:p>
@@ -14287,7 +13966,7 @@
                   <a:schemeClr val="accent1"/>
                 </a:solidFill>
               </a:rPr>
-              <a:t>Collection protocol (field data)</a:t>
+              <a:t>Recorded arrivals</a:t>
             </a:r>
             <a:endParaRPr lang="en-US" sz="1200" dirty="0"/>
           </a:p>
@@ -14304,7 +13983,7 @@
                   <a:schemeClr val="tx1"/>
                 </a:solidFill>
               </a:rPr>
-              <a:t>Count students entering the canteen in fixed 15-minute slots, 12:30–14:30, on working days (manual or permitted video), following Tang et al. (2019).</a:t>
+              <a:t>Number of students entering the canteen in each 15-minute slot, 12:30–13:15, on 40 consecutive days (5 Jan – 13 Feb 2026).</a:t>
             </a:r>
             <a:endParaRPr lang="en-US" sz="1200" dirty="0"/>
           </a:p>
@@ -14318,7 +13997,7 @@
                   <a:schemeClr val="accent1"/>
                 </a:solidFill>
               </a:rPr>
-              <a:t>Prototype dataset used now</a:t>
+              <a:t>Recorded attributes</a:t>
             </a:r>
             <a:endParaRPr lang="en-US" sz="1200" dirty="0"/>
           </a:p>
@@ -14335,7 +14014,7 @@
                   <a:schemeClr val="tx1"/>
                 </a:solidFill>
               </a:rPr>
-              <a:t>Synthetic semester from data_generator.py (seed 42): lunch rush near 13:15, weekday and exam-week effects, day-to-day variation. Not observed results.</a:t>
+              <a:t>Date, weekday, day type (Regular or Weekend), time slot and arrival count, in the interval-count style of Tang et al. (2019).</a:t>
             </a:r>
             <a:endParaRPr lang="en-US" sz="1200" dirty="0"/>
           </a:p>
@@ -14363,7 +14042,7 @@
                   <a:schemeClr val="tx1"/>
                 </a:solidFill>
               </a:rPr>
-              <a:t>Missing or invalid counts are dropped, not imputed, so the variance is not shrunk.</a:t>
+              <a:t>Missing or invalid counts are dropped, not imputed, so the variance is not shrunk. All 120 records passed.</a:t>
             </a:r>
             <a:endParaRPr lang="en-US" sz="1200" dirty="0"/>
           </a:p>
@@ -14402,7 +14081,7 @@
                 <a:ea typeface="Cambria" pitchFamily="34" charset="-122"/>
                 <a:cs typeface="Cambria" pitchFamily="34" charset="-120"/>
               </a:rPr>
-              <a:t>90</a:t>
+              <a:t>40</a:t>
             </a:r>
             <a:endParaRPr lang="en-US" sz="3200" dirty="0"/>
           </a:p>
@@ -14438,7 +14117,7 @@
                   <a:schemeClr val="tx1"/>
                 </a:solidFill>
               </a:rPr>
-              <a:t>working days (one 18-week semester)</a:t>
+              <a:t>consecutive days of counts</a:t>
             </a:r>
             <a:endParaRPr lang="en-US" sz="1200" dirty="0"/>
           </a:p>
@@ -14477,7 +14156,7 @@
                 <a:ea typeface="Cambria" pitchFamily="34" charset="-122"/>
                 <a:cs typeface="Cambria" pitchFamily="34" charset="-120"/>
               </a:rPr>
-              <a:t>8</a:t>
+              <a:t>3</a:t>
             </a:r>
             <a:endParaRPr lang="en-US" sz="3200" dirty="0"/>
           </a:p>
@@ -14552,7 +14231,7 @@
                 <a:ea typeface="Cambria" pitchFamily="34" charset="-122"/>
                 <a:cs typeface="Cambria" pitchFamily="34" charset="-120"/>
               </a:rPr>
-              <a:t>717</a:t>
+              <a:t>120</a:t>
             </a:r>
             <a:endParaRPr lang="en-US" sz="3200" dirty="0"/>
           </a:p>
@@ -14596,7 +14275,7 @@
       </p:sp>
       <p:sp>
         <p:nvSpPr>
-          <p:cNvPr id="11" name="dropped value"/>
+          <p:cNvPr id="11" name="day split value"/>
           <p:cNvSpPr txBox="1"/>
           <p:nvPr/>
         </p:nvSpPr>
@@ -14627,7 +14306,7 @@
                 <a:ea typeface="Cambria" pitchFamily="34" charset="-122"/>
                 <a:cs typeface="Cambria" pitchFamily="34" charset="-120"/>
               </a:rPr>
-              <a:t>3</a:t>
+              <a:t>30 + 10</a:t>
             </a:r>
             <a:endParaRPr lang="en-US" sz="3200" dirty="0"/>
           </a:p>
@@ -14635,7 +14314,7 @@
       </p:sp>
       <p:sp>
         <p:nvSpPr>
-          <p:cNvPr id="12" name="dropped label"/>
+          <p:cNvPr id="12" name="day split label"/>
           <p:cNvSpPr txBox="1"/>
           <p:nvPr/>
         </p:nvSpPr>
@@ -14663,7 +14342,7 @@
                   <a:schemeClr val="tx1"/>
                 </a:solidFill>
               </a:rPr>
-              <a:t>missing counts dropped (of 720)</a:t>
+              <a:t>weekdays + weekend days</a:t>
             </a:r>
             <a:endParaRPr lang="en-US" sz="1200" dirty="0"/>
           </a:p>
@@ -14671,7 +14350,7 @@
       </p:sp>
       <p:sp>
         <p:nvSpPr>
-          <p:cNvPr id="13" name="exam weeks value"/>
+          <p:cNvPr id="13" name="average count value"/>
           <p:cNvSpPr txBox="1"/>
           <p:nvPr/>
         </p:nvSpPr>
@@ -14702,7 +14381,7 @@
                 <a:ea typeface="Cambria" pitchFamily="34" charset="-122"/>
                 <a:cs typeface="Cambria" pitchFamily="34" charset="-120"/>
               </a:rPr>
-              <a:t>2</a:t>
+              <a:t>30.0</a:t>
             </a:r>
             <a:endParaRPr lang="en-US" sz="3200" dirty="0"/>
           </a:p>
@@ -14710,7 +14389,7 @@
       </p:sp>
       <p:sp>
         <p:nvSpPr>
-          <p:cNvPr id="14" name="exam weeks label"/>
+          <p:cNvPr id="14" name="average count label"/>
           <p:cNvSpPr txBox="1"/>
           <p:nvPr/>
         </p:nvSpPr>
@@ -14738,7 +14417,7 @@
                   <a:schemeClr val="tx1"/>
                 </a:solidFill>
               </a:rPr>
-              <a:t>exam weeks (weeks 9 and 18)</a:t>
+              <a:t>average arrivals per slot</a:t>
             </a:r>
             <a:endParaRPr lang="en-US" sz="1200" dirty="0"/>
           </a:p>
@@ -14777,7 +14456,7 @@
                 <a:ea typeface="Cambria" pitchFamily="34" charset="-122"/>
                 <a:cs typeface="Cambria" pitchFamily="34" charset="-120"/>
               </a:rPr>
-              <a:t>52</a:t>
+              <a:t>41</a:t>
             </a:r>
             <a:endParaRPr lang="en-US" sz="3200" dirty="0"/>
           </a:p>
@@ -16975,7 +16654,7 @@
                 <a:ea typeface="Cambria" pitchFamily="34" charset="-122"/>
                 <a:cs typeface="Cambria" pitchFamily="34" charset="-120"/>
               </a:rPr>
-              <a:t>Arrivals peak at 13:15–13:30, above capacity</a:t>
+              <a:t>Arrivals peak at 12:45–13:00, right at capacity</a:t>
             </a:r>
             <a:endParaRPr lang="en-US" sz="2800" dirty="0"/>
           </a:p>
@@ -17052,7 +16731,7 @@
                 <a:ea typeface="Cambria" pitchFamily="34" charset="-122"/>
                 <a:cs typeface="Cambria" pitchFamily="34" charset="-120"/>
               </a:rPr>
-              <a:t>34.4</a:t>
+              <a:t>31.5</a:t>
             </a:r>
             <a:endParaRPr lang="en-US" sz="3200" dirty="0"/>
           </a:p>
@@ -17088,7 +16767,7 @@
                   <a:schemeClr val="tx1"/>
                 </a:solidFill>
               </a:rPr>
-              <a:t>peak rate at 13:15–13:30; 95% CI [33.2, 35.6]</a:t>
+              <a:t>peak rate at 12:45–13:00; 95% CI [29.8, 33.3]</a:t>
             </a:r>
             <a:endParaRPr lang="en-US" sz="1200" dirty="0"/>
           </a:p>
@@ -17127,7 +16806,7 @@
                 <a:ea typeface="Cambria" pitchFamily="34" charset="-122"/>
                 <a:cs typeface="Cambria" pitchFamily="34" charset="-120"/>
               </a:rPr>
-              <a:t>16.3</a:t>
+              <a:t>27.9</a:t>
             </a:r>
             <a:endParaRPr lang="en-US" sz="3200" dirty="0"/>
           </a:p>
@@ -17163,7 +16842,7 @@
                   <a:schemeClr val="tx1"/>
                 </a:solidFill>
               </a:rPr>
-              <a:t>lowest rate at 14:15–14:30</a:t>
+              <a:t>lowest rate at 13:00–13:15</a:t>
             </a:r>
             <a:endParaRPr lang="en-US" sz="1200" dirty="0"/>
           </a:p>
@@ -17202,7 +16881,7 @@
                 <a:ea typeface="Cambria" pitchFamily="34" charset="-122"/>
                 <a:cs typeface="Cambria" pitchFamily="34" charset="-120"/>
               </a:rPr>
-              <a:t>2</a:t>
+              <a:t>2 of 3</a:t>
             </a:r>
             <a:endParaRPr lang="en-US" sz="3200" dirty="0"/>
           </a:p>
@@ -17668,7 +17347,7 @@
                           <a:ea typeface="Calibri" pitchFamily="34" charset="-122"/>
                           <a:cs typeface="Calibri" pitchFamily="34" charset="-120"/>
                         </a:rPr>
-                        <a:t>24.47</a:t>
+                        <a:t>30.52</a:t>
                       </a:r>
                       <a:endParaRPr lang="en-US" sz="1100" dirty="0">
                         <a:latin typeface="Calibri" charset="0"/>
@@ -17712,7 +17391,7 @@
                           <a:ea typeface="Calibri" pitchFamily="34" charset="-122"/>
                           <a:cs typeface="Calibri" pitchFamily="34" charset="-120"/>
                         </a:rPr>
-                        <a:t>1.09</a:t>
+                        <a:t>0.84</a:t>
                       </a:r>
                       <a:endParaRPr lang="en-US" sz="1100" dirty="0">
                         <a:latin typeface="Calibri" charset="0"/>
@@ -17756,7 +17435,7 @@
                           <a:ea typeface="Calibri" pitchFamily="34" charset="-122"/>
                           <a:cs typeface="Calibri" pitchFamily="34" charset="-120"/>
                         </a:rPr>
-                        <a:t>0.450</a:t>
+                        <a:t>0.890</a:t>
                       </a:r>
                       <a:endParaRPr lang="en-US" sz="1100" dirty="0">
                         <a:latin typeface="Calibri" charset="0"/>
@@ -17890,7 +17569,7 @@
                           <a:ea typeface="Calibri" pitchFamily="34" charset="-122"/>
                           <a:cs typeface="Calibri" pitchFamily="34" charset="-120"/>
                         </a:rPr>
-                        <a:t>29.42</a:t>
+                        <a:t>31.50</a:t>
                       </a:r>
                       <a:endParaRPr lang="en-US" sz="1100" dirty="0">
                         <a:latin typeface="Calibri" charset="0"/>
@@ -17934,7 +17613,7 @@
                           <a:ea typeface="Calibri" pitchFamily="34" charset="-122"/>
                           <a:cs typeface="Calibri" pitchFamily="34" charset="-120"/>
                         </a:rPr>
-                        <a:t>1.34</a:t>
+                        <a:t>0.88</a:t>
                       </a:r>
                       <a:endParaRPr lang="en-US" sz="1100" dirty="0">
                         <a:latin typeface="Calibri" charset="0"/>
@@ -17978,7 +17657,7 @@
                           <a:ea typeface="Calibri" pitchFamily="34" charset="-122"/>
                           <a:cs typeface="Calibri" pitchFamily="34" charset="-120"/>
                         </a:rPr>
-                        <a:t>0.552</a:t>
+                        <a:t>0.964</a:t>
                       </a:r>
                       <a:endParaRPr lang="en-US" sz="1100" dirty="0">
                         <a:latin typeface="Calibri" charset="0"/>
@@ -18112,7 +17791,7 @@
                           <a:ea typeface="Calibri" pitchFamily="34" charset="-122"/>
                           <a:cs typeface="Calibri" pitchFamily="34" charset="-120"/>
                         </a:rPr>
-                        <a:t>33.37</a:t>
+                        <a:t>27.88</a:t>
                       </a:r>
                       <a:endParaRPr lang="en-US" sz="1100" dirty="0">
                         <a:latin typeface="Calibri" charset="0"/>
@@ -18156,7 +17835,7 @@
                           <a:ea typeface="Calibri" pitchFamily="34" charset="-122"/>
                           <a:cs typeface="Calibri" pitchFamily="34" charset="-120"/>
                         </a:rPr>
-                        <a:t>1.26</a:t>
+                        <a:t>1.25</a:t>
                       </a:r>
                       <a:endParaRPr lang="en-US" sz="1100" dirty="0">
                         <a:latin typeface="Calibri" charset="0"/>
@@ -18200,7 +17879,7 @@
                           <a:ea typeface="Calibri" pitchFamily="34" charset="-122"/>
                           <a:cs typeface="Calibri" pitchFamily="34" charset="-120"/>
                         </a:rPr>
-                        <a:t>0.309</a:t>
+                        <a:t>0.331</a:t>
                       </a:r>
                       <a:endParaRPr lang="en-US" sz="1100" dirty="0">
                         <a:latin typeface="Calibri" charset="0"/>
@@ -18272,1116 +17951,6 @@
                   </a:tcPr>
                 </a:tc>
               </a:tr>
-              <a:tr h="329184">
-                <a:tc>
-                  <a:txBody>
-                    <a:bodyPr/>
-                    <a:lstStyle/>
-                    <a:p>
-                      <a:pPr algn="ctr" indent="0" marL="0">
-                        <a:buNone/>
-                      </a:pPr>
-                      <a:r>
-                        <a:rPr lang="en-US" sz="1100" dirty="0">
-                          <a:solidFill>
-                            <a:srgbClr val="1B2A4A"/>
-                          </a:solidFill>
-                          <a:latin typeface="Calibri" pitchFamily="34" charset="0"/>
-                          <a:ea typeface="Calibri" pitchFamily="34" charset="-122"/>
-                          <a:cs typeface="Calibri" pitchFamily="34" charset="-120"/>
-                        </a:rPr>
-                        <a:t>13:15-13:30</a:t>
-                      </a:r>
-                      <a:endParaRPr lang="en-US" sz="1100" dirty="0">
-                        <a:latin typeface="Calibri" charset="0"/>
-                        <a:ea typeface="Calibri" charset="0"/>
-                        <a:cs typeface="Calibri" charset="0"/>
-                      </a:endParaRPr>
-                    </a:p>
-                  </a:txBody>
-                  <a:tcPr marL="91440" marR="91440" marT="45720" marB="45720" anchor="ctr">
-                    <a:lnL w="0" cap="flat" cmpd="sng" algn="ctr">
-                      <a:noFill/>
-                    </a:lnL>
-                    <a:lnR w="0" cap="flat" cmpd="sng" algn="ctr">
-                      <a:noFill/>
-                    </a:lnR>
-                    <a:lnT w="0" cap="flat" cmpd="sng" algn="ctr">
-                      <a:noFill/>
-                    </a:lnT>
-                    <a:lnB w="0" cap="flat" cmpd="sng" algn="ctr">
-                      <a:noFill/>
-                    </a:lnB>
-                    <a:solidFill>
-                      <a:srgbClr val="FFFFFF"/>
-                    </a:solidFill>
-                  </a:tcPr>
-                </a:tc>
-                <a:tc>
-                  <a:txBody>
-                    <a:bodyPr/>
-                    <a:lstStyle/>
-                    <a:p>
-                      <a:pPr algn="ctr" indent="0" marL="0">
-                        <a:buNone/>
-                      </a:pPr>
-                      <a:r>
-                        <a:rPr lang="en-US" sz="1100" dirty="0">
-                          <a:solidFill>
-                            <a:srgbClr val="1B2A4A"/>
-                          </a:solidFill>
-                          <a:latin typeface="Calibri" pitchFamily="34" charset="0"/>
-                          <a:ea typeface="Calibri" pitchFamily="34" charset="-122"/>
-                          <a:cs typeface="Calibri" pitchFamily="34" charset="-120"/>
-                        </a:rPr>
-                        <a:t>34.36</a:t>
-                      </a:r>
-                      <a:endParaRPr lang="en-US" sz="1100" dirty="0">
-                        <a:latin typeface="Calibri" charset="0"/>
-                        <a:ea typeface="Calibri" charset="0"/>
-                        <a:cs typeface="Calibri" charset="0"/>
-                      </a:endParaRPr>
-                    </a:p>
-                  </a:txBody>
-                  <a:tcPr marL="91440" marR="91440" marT="45720" marB="45720" anchor="ctr">
-                    <a:lnL w="0" cap="flat" cmpd="sng" algn="ctr">
-                      <a:noFill/>
-                    </a:lnL>
-                    <a:lnR w="0" cap="flat" cmpd="sng" algn="ctr">
-                      <a:noFill/>
-                    </a:lnR>
-                    <a:lnT w="0" cap="flat" cmpd="sng" algn="ctr">
-                      <a:noFill/>
-                    </a:lnT>
-                    <a:lnB w="0" cap="flat" cmpd="sng" algn="ctr">
-                      <a:noFill/>
-                    </a:lnB>
-                    <a:solidFill>
-                      <a:srgbClr val="FFFFFF"/>
-                    </a:solidFill>
-                  </a:tcPr>
-                </a:tc>
-                <a:tc>
-                  <a:txBody>
-                    <a:bodyPr/>
-                    <a:lstStyle/>
-                    <a:p>
-                      <a:pPr algn="ctr" indent="0" marL="0">
-                        <a:buNone/>
-                      </a:pPr>
-                      <a:r>
-                        <a:rPr lang="en-US" sz="1100" dirty="0">
-                          <a:solidFill>
-                            <a:srgbClr val="1B2A4A"/>
-                          </a:solidFill>
-                          <a:latin typeface="Calibri" pitchFamily="34" charset="0"/>
-                          <a:ea typeface="Calibri" pitchFamily="34" charset="-122"/>
-                          <a:cs typeface="Calibri" pitchFamily="34" charset="-120"/>
-                        </a:rPr>
-                        <a:t>1.10</a:t>
-                      </a:r>
-                      <a:endParaRPr lang="en-US" sz="1100" dirty="0">
-                        <a:latin typeface="Calibri" charset="0"/>
-                        <a:ea typeface="Calibri" charset="0"/>
-                        <a:cs typeface="Calibri" charset="0"/>
-                      </a:endParaRPr>
-                    </a:p>
-                  </a:txBody>
-                  <a:tcPr marL="91440" marR="91440" marT="45720" marB="45720" anchor="ctr">
-                    <a:lnL w="0" cap="flat" cmpd="sng" algn="ctr">
-                      <a:noFill/>
-                    </a:lnL>
-                    <a:lnR w="0" cap="flat" cmpd="sng" algn="ctr">
-                      <a:noFill/>
-                    </a:lnR>
-                    <a:lnT w="0" cap="flat" cmpd="sng" algn="ctr">
-                      <a:noFill/>
-                    </a:lnT>
-                    <a:lnB w="0" cap="flat" cmpd="sng" algn="ctr">
-                      <a:noFill/>
-                    </a:lnB>
-                    <a:solidFill>
-                      <a:srgbClr val="FFFFFF"/>
-                    </a:solidFill>
-                  </a:tcPr>
-                </a:tc>
-                <a:tc>
-                  <a:txBody>
-                    <a:bodyPr/>
-                    <a:lstStyle/>
-                    <a:p>
-                      <a:pPr algn="ctr" indent="0" marL="0">
-                        <a:buNone/>
-                      </a:pPr>
-                      <a:r>
-                        <a:rPr lang="en-US" sz="1100" dirty="0">
-                          <a:solidFill>
-                            <a:srgbClr val="1B2A4A"/>
-                          </a:solidFill>
-                          <a:latin typeface="Calibri" pitchFamily="34" charset="0"/>
-                          <a:ea typeface="Calibri" pitchFamily="34" charset="-122"/>
-                          <a:cs typeface="Calibri" pitchFamily="34" charset="-120"/>
-                        </a:rPr>
-                        <a:t>0.701</a:t>
-                      </a:r>
-                      <a:endParaRPr lang="en-US" sz="1100" dirty="0">
-                        <a:latin typeface="Calibri" charset="0"/>
-                        <a:ea typeface="Calibri" charset="0"/>
-                        <a:cs typeface="Calibri" charset="0"/>
-                      </a:endParaRPr>
-                    </a:p>
-                  </a:txBody>
-                  <a:tcPr marL="91440" marR="91440" marT="45720" marB="45720" anchor="ctr">
-                    <a:lnL w="0" cap="flat" cmpd="sng" algn="ctr">
-                      <a:noFill/>
-                    </a:lnL>
-                    <a:lnR w="0" cap="flat" cmpd="sng" algn="ctr">
-                      <a:noFill/>
-                    </a:lnR>
-                    <a:lnT w="0" cap="flat" cmpd="sng" algn="ctr">
-                      <a:noFill/>
-                    </a:lnT>
-                    <a:lnB w="0" cap="flat" cmpd="sng" algn="ctr">
-                      <a:noFill/>
-                    </a:lnB>
-                    <a:solidFill>
-                      <a:srgbClr val="FFFFFF"/>
-                    </a:solidFill>
-                  </a:tcPr>
-                </a:tc>
-                <a:tc>
-                  <a:txBody>
-                    <a:bodyPr/>
-                    <a:lstStyle/>
-                    <a:p>
-                      <a:pPr algn="ctr" indent="0" marL="0">
-                        <a:buNone/>
-                      </a:pPr>
-                      <a:r>
-                        <a:rPr lang="en-US" sz="1100" dirty="0">
-                          <a:solidFill>
-                            <a:srgbClr val="1B2A4A"/>
-                          </a:solidFill>
-                          <a:latin typeface="Calibri" pitchFamily="34" charset="0"/>
-                          <a:ea typeface="Calibri" pitchFamily="34" charset="-122"/>
-                          <a:cs typeface="Calibri" pitchFamily="34" charset="-120"/>
-                        </a:rPr>
-                        <a:t>Fit OK</a:t>
-                      </a:r>
-                      <a:endParaRPr lang="en-US" sz="1100" dirty="0">
-                        <a:latin typeface="Calibri" charset="0"/>
-                        <a:ea typeface="Calibri" charset="0"/>
-                        <a:cs typeface="Calibri" charset="0"/>
-                      </a:endParaRPr>
-                    </a:p>
-                  </a:txBody>
-                  <a:tcPr marL="91440" marR="91440" marT="45720" marB="45720" anchor="ctr">
-                    <a:lnL w="0" cap="flat" cmpd="sng" algn="ctr">
-                      <a:noFill/>
-                    </a:lnL>
-                    <a:lnR w="0" cap="flat" cmpd="sng" algn="ctr">
-                      <a:noFill/>
-                    </a:lnR>
-                    <a:lnT w="0" cap="flat" cmpd="sng" algn="ctr">
-                      <a:noFill/>
-                    </a:lnT>
-                    <a:lnB w="0" cap="flat" cmpd="sng" algn="ctr">
-                      <a:noFill/>
-                    </a:lnB>
-                    <a:solidFill>
-                      <a:srgbClr val="FFFFFF"/>
-                    </a:solidFill>
-                  </a:tcPr>
-                </a:tc>
-              </a:tr>
-              <a:tr h="329184">
-                <a:tc>
-                  <a:txBody>
-                    <a:bodyPr/>
-                    <a:lstStyle/>
-                    <a:p>
-                      <a:pPr algn="ctr" indent="0" marL="0">
-                        <a:buNone/>
-                      </a:pPr>
-                      <a:r>
-                        <a:rPr lang="en-US" sz="1100" dirty="0">
-                          <a:solidFill>
-                            <a:srgbClr val="1B2A4A"/>
-                          </a:solidFill>
-                          <a:latin typeface="Calibri" pitchFamily="34" charset="0"/>
-                          <a:ea typeface="Calibri" pitchFamily="34" charset="-122"/>
-                          <a:cs typeface="Calibri" pitchFamily="34" charset="-120"/>
-                        </a:rPr>
-                        <a:t>13:30-13:45</a:t>
-                      </a:r>
-                      <a:endParaRPr lang="en-US" sz="1100" dirty="0">
-                        <a:latin typeface="Calibri" charset="0"/>
-                        <a:ea typeface="Calibri" charset="0"/>
-                        <a:cs typeface="Calibri" charset="0"/>
-                      </a:endParaRPr>
-                    </a:p>
-                  </a:txBody>
-                  <a:tcPr marL="91440" marR="91440" marT="45720" marB="45720" anchor="ctr">
-                    <a:lnL w="0" cap="flat" cmpd="sng" algn="ctr">
-                      <a:noFill/>
-                    </a:lnL>
-                    <a:lnR w="0" cap="flat" cmpd="sng" algn="ctr">
-                      <a:noFill/>
-                    </a:lnR>
-                    <a:lnT w="0" cap="flat" cmpd="sng" algn="ctr">
-                      <a:noFill/>
-                    </a:lnT>
-                    <a:lnB w="0" cap="flat" cmpd="sng" algn="ctr">
-                      <a:noFill/>
-                    </a:lnB>
-                    <a:solidFill>
-                      <a:srgbClr val="EEF3F6"/>
-                    </a:solidFill>
-                  </a:tcPr>
-                </a:tc>
-                <a:tc>
-                  <a:txBody>
-                    <a:bodyPr/>
-                    <a:lstStyle/>
-                    <a:p>
-                      <a:pPr algn="ctr" indent="0" marL="0">
-                        <a:buNone/>
-                      </a:pPr>
-                      <a:r>
-                        <a:rPr lang="en-US" sz="1100" dirty="0">
-                          <a:solidFill>
-                            <a:srgbClr val="1B2A4A"/>
-                          </a:solidFill>
-                          <a:latin typeface="Calibri" pitchFamily="34" charset="0"/>
-                          <a:ea typeface="Calibri" pitchFamily="34" charset="-122"/>
-                          <a:cs typeface="Calibri" pitchFamily="34" charset="-120"/>
-                        </a:rPr>
-                        <a:t>29.04</a:t>
-                      </a:r>
-                      <a:endParaRPr lang="en-US" sz="1100" dirty="0">
-                        <a:latin typeface="Calibri" charset="0"/>
-                        <a:ea typeface="Calibri" charset="0"/>
-                        <a:cs typeface="Calibri" charset="0"/>
-                      </a:endParaRPr>
-                    </a:p>
-                  </a:txBody>
-                  <a:tcPr marL="91440" marR="91440" marT="45720" marB="45720" anchor="ctr">
-                    <a:lnL w="0" cap="flat" cmpd="sng" algn="ctr">
-                      <a:noFill/>
-                    </a:lnL>
-                    <a:lnR w="0" cap="flat" cmpd="sng" algn="ctr">
-                      <a:noFill/>
-                    </a:lnR>
-                    <a:lnT w="0" cap="flat" cmpd="sng" algn="ctr">
-                      <a:noFill/>
-                    </a:lnT>
-                    <a:lnB w="0" cap="flat" cmpd="sng" algn="ctr">
-                      <a:noFill/>
-                    </a:lnB>
-                    <a:solidFill>
-                      <a:srgbClr val="EEF3F6"/>
-                    </a:solidFill>
-                  </a:tcPr>
-                </a:tc>
-                <a:tc>
-                  <a:txBody>
-                    <a:bodyPr/>
-                    <a:lstStyle/>
-                    <a:p>
-                      <a:pPr algn="ctr" indent="0" marL="0">
-                        <a:buNone/>
-                      </a:pPr>
-                      <a:r>
-                        <a:rPr lang="en-US" sz="1100" dirty="0">
-                          <a:solidFill>
-                            <a:srgbClr val="1B2A4A"/>
-                          </a:solidFill>
-                          <a:latin typeface="Calibri" pitchFamily="34" charset="0"/>
-                          <a:ea typeface="Calibri" pitchFamily="34" charset="-122"/>
-                          <a:cs typeface="Calibri" pitchFamily="34" charset="-120"/>
-                        </a:rPr>
-                        <a:t>1.03</a:t>
-                      </a:r>
-                      <a:endParaRPr lang="en-US" sz="1100" dirty="0">
-                        <a:latin typeface="Calibri" charset="0"/>
-                        <a:ea typeface="Calibri" charset="0"/>
-                        <a:cs typeface="Calibri" charset="0"/>
-                      </a:endParaRPr>
-                    </a:p>
-                  </a:txBody>
-                  <a:tcPr marL="91440" marR="91440" marT="45720" marB="45720" anchor="ctr">
-                    <a:lnL w="0" cap="flat" cmpd="sng" algn="ctr">
-                      <a:noFill/>
-                    </a:lnL>
-                    <a:lnR w="0" cap="flat" cmpd="sng" algn="ctr">
-                      <a:noFill/>
-                    </a:lnR>
-                    <a:lnT w="0" cap="flat" cmpd="sng" algn="ctr">
-                      <a:noFill/>
-                    </a:lnT>
-                    <a:lnB w="0" cap="flat" cmpd="sng" algn="ctr">
-                      <a:noFill/>
-                    </a:lnB>
-                    <a:solidFill>
-                      <a:srgbClr val="EEF3F6"/>
-                    </a:solidFill>
-                  </a:tcPr>
-                </a:tc>
-                <a:tc>
-                  <a:txBody>
-                    <a:bodyPr/>
-                    <a:lstStyle/>
-                    <a:p>
-                      <a:pPr algn="ctr" indent="0" marL="0">
-                        <a:buNone/>
-                      </a:pPr>
-                      <a:r>
-                        <a:rPr lang="en-US" sz="1100" dirty="0">
-                          <a:solidFill>
-                            <a:srgbClr val="1B2A4A"/>
-                          </a:solidFill>
-                          <a:latin typeface="Calibri" pitchFamily="34" charset="0"/>
-                          <a:ea typeface="Calibri" pitchFamily="34" charset="-122"/>
-                          <a:cs typeface="Calibri" pitchFamily="34" charset="-120"/>
-                        </a:rPr>
-                        <a:t>0.218</a:t>
-                      </a:r>
-                      <a:endParaRPr lang="en-US" sz="1100" dirty="0">
-                        <a:latin typeface="Calibri" charset="0"/>
-                        <a:ea typeface="Calibri" charset="0"/>
-                        <a:cs typeface="Calibri" charset="0"/>
-                      </a:endParaRPr>
-                    </a:p>
-                  </a:txBody>
-                  <a:tcPr marL="91440" marR="91440" marT="45720" marB="45720" anchor="ctr">
-                    <a:lnL w="0" cap="flat" cmpd="sng" algn="ctr">
-                      <a:noFill/>
-                    </a:lnL>
-                    <a:lnR w="0" cap="flat" cmpd="sng" algn="ctr">
-                      <a:noFill/>
-                    </a:lnR>
-                    <a:lnT w="0" cap="flat" cmpd="sng" algn="ctr">
-                      <a:noFill/>
-                    </a:lnT>
-                    <a:lnB w="0" cap="flat" cmpd="sng" algn="ctr">
-                      <a:noFill/>
-                    </a:lnB>
-                    <a:solidFill>
-                      <a:srgbClr val="EEF3F6"/>
-                    </a:solidFill>
-                  </a:tcPr>
-                </a:tc>
-                <a:tc>
-                  <a:txBody>
-                    <a:bodyPr/>
-                    <a:lstStyle/>
-                    <a:p>
-                      <a:pPr algn="ctr" indent="0" marL="0">
-                        <a:buNone/>
-                      </a:pPr>
-                      <a:r>
-                        <a:rPr lang="en-US" sz="1100" dirty="0">
-                          <a:solidFill>
-                            <a:srgbClr val="1B2A4A"/>
-                          </a:solidFill>
-                          <a:latin typeface="Calibri" pitchFamily="34" charset="0"/>
-                          <a:ea typeface="Calibri" pitchFamily="34" charset="-122"/>
-                          <a:cs typeface="Calibri" pitchFamily="34" charset="-120"/>
-                        </a:rPr>
-                        <a:t>Fit OK</a:t>
-                      </a:r>
-                      <a:endParaRPr lang="en-US" sz="1100" dirty="0">
-                        <a:latin typeface="Calibri" charset="0"/>
-                        <a:ea typeface="Calibri" charset="0"/>
-                        <a:cs typeface="Calibri" charset="0"/>
-                      </a:endParaRPr>
-                    </a:p>
-                  </a:txBody>
-                  <a:tcPr marL="91440" marR="91440" marT="45720" marB="45720" anchor="ctr">
-                    <a:lnL w="0" cap="flat" cmpd="sng" algn="ctr">
-                      <a:noFill/>
-                    </a:lnL>
-                    <a:lnR w="0" cap="flat" cmpd="sng" algn="ctr">
-                      <a:noFill/>
-                    </a:lnR>
-                    <a:lnT w="0" cap="flat" cmpd="sng" algn="ctr">
-                      <a:noFill/>
-                    </a:lnT>
-                    <a:lnB w="0" cap="flat" cmpd="sng" algn="ctr">
-                      <a:noFill/>
-                    </a:lnB>
-                    <a:solidFill>
-                      <a:srgbClr val="EEF3F6"/>
-                    </a:solidFill>
-                  </a:tcPr>
-                </a:tc>
-              </a:tr>
-              <a:tr h="329184">
-                <a:tc>
-                  <a:txBody>
-                    <a:bodyPr/>
-                    <a:lstStyle/>
-                    <a:p>
-                      <a:pPr algn="ctr" indent="0" marL="0">
-                        <a:buNone/>
-                      </a:pPr>
-                      <a:r>
-                        <a:rPr lang="en-US" sz="1100" dirty="0">
-                          <a:solidFill>
-                            <a:srgbClr val="1B2A4A"/>
-                          </a:solidFill>
-                          <a:latin typeface="Calibri" pitchFamily="34" charset="0"/>
-                          <a:ea typeface="Calibri" pitchFamily="34" charset="-122"/>
-                          <a:cs typeface="Calibri" pitchFamily="34" charset="-120"/>
-                        </a:rPr>
-                        <a:t>13:45-14:00</a:t>
-                      </a:r>
-                      <a:endParaRPr lang="en-US" sz="1100" dirty="0">
-                        <a:latin typeface="Calibri" charset="0"/>
-                        <a:ea typeface="Calibri" charset="0"/>
-                        <a:cs typeface="Calibri" charset="0"/>
-                      </a:endParaRPr>
-                    </a:p>
-                  </a:txBody>
-                  <a:tcPr marL="91440" marR="91440" marT="45720" marB="45720" anchor="ctr">
-                    <a:lnL w="0" cap="flat" cmpd="sng" algn="ctr">
-                      <a:noFill/>
-                    </a:lnL>
-                    <a:lnR w="0" cap="flat" cmpd="sng" algn="ctr">
-                      <a:noFill/>
-                    </a:lnR>
-                    <a:lnT w="0" cap="flat" cmpd="sng" algn="ctr">
-                      <a:noFill/>
-                    </a:lnT>
-                    <a:lnB w="0" cap="flat" cmpd="sng" algn="ctr">
-                      <a:noFill/>
-                    </a:lnB>
-                    <a:solidFill>
-                      <a:srgbClr val="FFFFFF"/>
-                    </a:solidFill>
-                  </a:tcPr>
-                </a:tc>
-                <a:tc>
-                  <a:txBody>
-                    <a:bodyPr/>
-                    <a:lstStyle/>
-                    <a:p>
-                      <a:pPr algn="ctr" indent="0" marL="0">
-                        <a:buNone/>
-                      </a:pPr>
-                      <a:r>
-                        <a:rPr lang="en-US" sz="1100" dirty="0">
-                          <a:solidFill>
-                            <a:srgbClr val="1B2A4A"/>
-                          </a:solidFill>
-                          <a:latin typeface="Calibri" pitchFamily="34" charset="0"/>
-                          <a:ea typeface="Calibri" pitchFamily="34" charset="-122"/>
-                          <a:cs typeface="Calibri" pitchFamily="34" charset="-120"/>
-                        </a:rPr>
-                        <a:t>24.72</a:t>
-                      </a:r>
-                      <a:endParaRPr lang="en-US" sz="1100" dirty="0">
-                        <a:latin typeface="Calibri" charset="0"/>
-                        <a:ea typeface="Calibri" charset="0"/>
-                        <a:cs typeface="Calibri" charset="0"/>
-                      </a:endParaRPr>
-                    </a:p>
-                  </a:txBody>
-                  <a:tcPr marL="91440" marR="91440" marT="45720" marB="45720" anchor="ctr">
-                    <a:lnL w="0" cap="flat" cmpd="sng" algn="ctr">
-                      <a:noFill/>
-                    </a:lnL>
-                    <a:lnR w="0" cap="flat" cmpd="sng" algn="ctr">
-                      <a:noFill/>
-                    </a:lnR>
-                    <a:lnT w="0" cap="flat" cmpd="sng" algn="ctr">
-                      <a:noFill/>
-                    </a:lnT>
-                    <a:lnB w="0" cap="flat" cmpd="sng" algn="ctr">
-                      <a:noFill/>
-                    </a:lnB>
-                    <a:solidFill>
-                      <a:srgbClr val="FFFFFF"/>
-                    </a:solidFill>
-                  </a:tcPr>
-                </a:tc>
-                <a:tc>
-                  <a:txBody>
-                    <a:bodyPr/>
-                    <a:lstStyle/>
-                    <a:p>
-                      <a:pPr algn="ctr" indent="0" marL="0">
-                        <a:buNone/>
-                      </a:pPr>
-                      <a:r>
-                        <a:rPr lang="en-US" sz="1100" dirty="0">
-                          <a:solidFill>
-                            <a:srgbClr val="1B2A4A"/>
-                          </a:solidFill>
-                          <a:latin typeface="Calibri" pitchFamily="34" charset="0"/>
-                          <a:ea typeface="Calibri" pitchFamily="34" charset="-122"/>
-                          <a:cs typeface="Calibri" pitchFamily="34" charset="-120"/>
-                        </a:rPr>
-                        <a:t>1.25</a:t>
-                      </a:r>
-                      <a:endParaRPr lang="en-US" sz="1100" dirty="0">
-                        <a:latin typeface="Calibri" charset="0"/>
-                        <a:ea typeface="Calibri" charset="0"/>
-                        <a:cs typeface="Calibri" charset="0"/>
-                      </a:endParaRPr>
-                    </a:p>
-                  </a:txBody>
-                  <a:tcPr marL="91440" marR="91440" marT="45720" marB="45720" anchor="ctr">
-                    <a:lnL w="0" cap="flat" cmpd="sng" algn="ctr">
-                      <a:noFill/>
-                    </a:lnL>
-                    <a:lnR w="0" cap="flat" cmpd="sng" algn="ctr">
-                      <a:noFill/>
-                    </a:lnR>
-                    <a:lnT w="0" cap="flat" cmpd="sng" algn="ctr">
-                      <a:noFill/>
-                    </a:lnT>
-                    <a:lnB w="0" cap="flat" cmpd="sng" algn="ctr">
-                      <a:noFill/>
-                    </a:lnB>
-                    <a:solidFill>
-                      <a:srgbClr val="FFFFFF"/>
-                    </a:solidFill>
-                  </a:tcPr>
-                </a:tc>
-                <a:tc>
-                  <a:txBody>
-                    <a:bodyPr/>
-                    <a:lstStyle/>
-                    <a:p>
-                      <a:pPr algn="ctr" indent="0" marL="0">
-                        <a:buNone/>
-                      </a:pPr>
-                      <a:r>
-                        <a:rPr lang="en-US" sz="1100" dirty="0">
-                          <a:solidFill>
-                            <a:srgbClr val="1B2A4A"/>
-                          </a:solidFill>
-                          <a:latin typeface="Calibri" pitchFamily="34" charset="0"/>
-                          <a:ea typeface="Calibri" pitchFamily="34" charset="-122"/>
-                          <a:cs typeface="Calibri" pitchFamily="34" charset="-120"/>
-                        </a:rPr>
-                        <a:t>0.310</a:t>
-                      </a:r>
-                      <a:endParaRPr lang="en-US" sz="1100" dirty="0">
-                        <a:latin typeface="Calibri" charset="0"/>
-                        <a:ea typeface="Calibri" charset="0"/>
-                        <a:cs typeface="Calibri" charset="0"/>
-                      </a:endParaRPr>
-                    </a:p>
-                  </a:txBody>
-                  <a:tcPr marL="91440" marR="91440" marT="45720" marB="45720" anchor="ctr">
-                    <a:lnL w="0" cap="flat" cmpd="sng" algn="ctr">
-                      <a:noFill/>
-                    </a:lnL>
-                    <a:lnR w="0" cap="flat" cmpd="sng" algn="ctr">
-                      <a:noFill/>
-                    </a:lnR>
-                    <a:lnT w="0" cap="flat" cmpd="sng" algn="ctr">
-                      <a:noFill/>
-                    </a:lnT>
-                    <a:lnB w="0" cap="flat" cmpd="sng" algn="ctr">
-                      <a:noFill/>
-                    </a:lnB>
-                    <a:solidFill>
-                      <a:srgbClr val="FFFFFF"/>
-                    </a:solidFill>
-                  </a:tcPr>
-                </a:tc>
-                <a:tc>
-                  <a:txBody>
-                    <a:bodyPr/>
-                    <a:lstStyle/>
-                    <a:p>
-                      <a:pPr algn="ctr" indent="0" marL="0">
-                        <a:buNone/>
-                      </a:pPr>
-                      <a:r>
-                        <a:rPr lang="en-US" sz="1100" dirty="0">
-                          <a:solidFill>
-                            <a:srgbClr val="1B2A4A"/>
-                          </a:solidFill>
-                          <a:latin typeface="Calibri" pitchFamily="34" charset="0"/>
-                          <a:ea typeface="Calibri" pitchFamily="34" charset="-122"/>
-                          <a:cs typeface="Calibri" pitchFamily="34" charset="-120"/>
-                        </a:rPr>
-                        <a:t>Fit OK</a:t>
-                      </a:r>
-                      <a:endParaRPr lang="en-US" sz="1100" dirty="0">
-                        <a:latin typeface="Calibri" charset="0"/>
-                        <a:ea typeface="Calibri" charset="0"/>
-                        <a:cs typeface="Calibri" charset="0"/>
-                      </a:endParaRPr>
-                    </a:p>
-                  </a:txBody>
-                  <a:tcPr marL="91440" marR="91440" marT="45720" marB="45720" anchor="ctr">
-                    <a:lnL w="0" cap="flat" cmpd="sng" algn="ctr">
-                      <a:noFill/>
-                    </a:lnL>
-                    <a:lnR w="0" cap="flat" cmpd="sng" algn="ctr">
-                      <a:noFill/>
-                    </a:lnR>
-                    <a:lnT w="0" cap="flat" cmpd="sng" algn="ctr">
-                      <a:noFill/>
-                    </a:lnT>
-                    <a:lnB w="0" cap="flat" cmpd="sng" algn="ctr">
-                      <a:noFill/>
-                    </a:lnB>
-                    <a:solidFill>
-                      <a:srgbClr val="FFFFFF"/>
-                    </a:solidFill>
-                  </a:tcPr>
-                </a:tc>
-              </a:tr>
-              <a:tr h="329184">
-                <a:tc>
-                  <a:txBody>
-                    <a:bodyPr/>
-                    <a:lstStyle/>
-                    <a:p>
-                      <a:pPr algn="ctr" indent="0" marL="0">
-                        <a:buNone/>
-                      </a:pPr>
-                      <a:r>
-                        <a:rPr lang="en-US" sz="1100" dirty="0">
-                          <a:solidFill>
-                            <a:srgbClr val="1B2A4A"/>
-                          </a:solidFill>
-                          <a:latin typeface="Calibri" pitchFamily="34" charset="0"/>
-                          <a:ea typeface="Calibri" pitchFamily="34" charset="-122"/>
-                          <a:cs typeface="Calibri" pitchFamily="34" charset="-120"/>
-                        </a:rPr>
-                        <a:t>14:00-14:15</a:t>
-                      </a:r>
-                      <a:endParaRPr lang="en-US" sz="1100" dirty="0">
-                        <a:latin typeface="Calibri" charset="0"/>
-                        <a:ea typeface="Calibri" charset="0"/>
-                        <a:cs typeface="Calibri" charset="0"/>
-                      </a:endParaRPr>
-                    </a:p>
-                  </a:txBody>
-                  <a:tcPr marL="91440" marR="91440" marT="45720" marB="45720" anchor="ctr">
-                    <a:lnL w="0" cap="flat" cmpd="sng" algn="ctr">
-                      <a:noFill/>
-                    </a:lnL>
-                    <a:lnR w="0" cap="flat" cmpd="sng" algn="ctr">
-                      <a:noFill/>
-                    </a:lnR>
-                    <a:lnT w="0" cap="flat" cmpd="sng" algn="ctr">
-                      <a:noFill/>
-                    </a:lnT>
-                    <a:lnB w="0" cap="flat" cmpd="sng" algn="ctr">
-                      <a:noFill/>
-                    </a:lnB>
-                    <a:solidFill>
-                      <a:srgbClr val="EEF3F6"/>
-                    </a:solidFill>
-                  </a:tcPr>
-                </a:tc>
-                <a:tc>
-                  <a:txBody>
-                    <a:bodyPr/>
-                    <a:lstStyle/>
-                    <a:p>
-                      <a:pPr algn="ctr" indent="0" marL="0">
-                        <a:buNone/>
-                      </a:pPr>
-                      <a:r>
-                        <a:rPr lang="en-US" sz="1100" dirty="0">
-                          <a:solidFill>
-                            <a:srgbClr val="1B2A4A"/>
-                          </a:solidFill>
-                          <a:latin typeface="Calibri" pitchFamily="34" charset="0"/>
-                          <a:ea typeface="Calibri" pitchFamily="34" charset="-122"/>
-                          <a:cs typeface="Calibri" pitchFamily="34" charset="-120"/>
-                        </a:rPr>
-                        <a:t>19.12</a:t>
-                      </a:r>
-                      <a:endParaRPr lang="en-US" sz="1100" dirty="0">
-                        <a:latin typeface="Calibri" charset="0"/>
-                        <a:ea typeface="Calibri" charset="0"/>
-                        <a:cs typeface="Calibri" charset="0"/>
-                      </a:endParaRPr>
-                    </a:p>
-                  </a:txBody>
-                  <a:tcPr marL="91440" marR="91440" marT="45720" marB="45720" anchor="ctr">
-                    <a:lnL w="0" cap="flat" cmpd="sng" algn="ctr">
-                      <a:noFill/>
-                    </a:lnL>
-                    <a:lnR w="0" cap="flat" cmpd="sng" algn="ctr">
-                      <a:noFill/>
-                    </a:lnR>
-                    <a:lnT w="0" cap="flat" cmpd="sng" algn="ctr">
-                      <a:noFill/>
-                    </a:lnT>
-                    <a:lnB w="0" cap="flat" cmpd="sng" algn="ctr">
-                      <a:noFill/>
-                    </a:lnB>
-                    <a:solidFill>
-                      <a:srgbClr val="EEF3F6"/>
-                    </a:solidFill>
-                  </a:tcPr>
-                </a:tc>
-                <a:tc>
-                  <a:txBody>
-                    <a:bodyPr/>
-                    <a:lstStyle/>
-                    <a:p>
-                      <a:pPr algn="ctr" indent="0" marL="0">
-                        <a:buNone/>
-                      </a:pPr>
-                      <a:r>
-                        <a:rPr lang="en-US" sz="1100" dirty="0">
-                          <a:solidFill>
-                            <a:srgbClr val="1B2A4A"/>
-                          </a:solidFill>
-                          <a:latin typeface="Calibri" pitchFamily="34" charset="0"/>
-                          <a:ea typeface="Calibri" pitchFamily="34" charset="-122"/>
-                          <a:cs typeface="Calibri" pitchFamily="34" charset="-120"/>
-                        </a:rPr>
-                        <a:t>1.34</a:t>
-                      </a:r>
-                      <a:endParaRPr lang="en-US" sz="1100" dirty="0">
-                        <a:latin typeface="Calibri" charset="0"/>
-                        <a:ea typeface="Calibri" charset="0"/>
-                        <a:cs typeface="Calibri" charset="0"/>
-                      </a:endParaRPr>
-                    </a:p>
-                  </a:txBody>
-                  <a:tcPr marL="91440" marR="91440" marT="45720" marB="45720" anchor="ctr">
-                    <a:lnL w="0" cap="flat" cmpd="sng" algn="ctr">
-                      <a:noFill/>
-                    </a:lnL>
-                    <a:lnR w="0" cap="flat" cmpd="sng" algn="ctr">
-                      <a:noFill/>
-                    </a:lnR>
-                    <a:lnT w="0" cap="flat" cmpd="sng" algn="ctr">
-                      <a:noFill/>
-                    </a:lnT>
-                    <a:lnB w="0" cap="flat" cmpd="sng" algn="ctr">
-                      <a:noFill/>
-                    </a:lnB>
-                    <a:solidFill>
-                      <a:srgbClr val="EEF3F6"/>
-                    </a:solidFill>
-                  </a:tcPr>
-                </a:tc>
-                <a:tc>
-                  <a:txBody>
-                    <a:bodyPr/>
-                    <a:lstStyle/>
-                    <a:p>
-                      <a:pPr algn="ctr" indent="0" marL="0">
-                        <a:buNone/>
-                      </a:pPr>
-                      <a:r>
-                        <a:rPr lang="en-US" sz="1100" dirty="0">
-                          <a:solidFill>
-                            <a:srgbClr val="1B2A4A"/>
-                          </a:solidFill>
-                          <a:latin typeface="Calibri" pitchFamily="34" charset="0"/>
-                          <a:ea typeface="Calibri" pitchFamily="34" charset="-122"/>
-                          <a:cs typeface="Calibri" pitchFamily="34" charset="-120"/>
-                        </a:rPr>
-                        <a:t>0.148</a:t>
-                      </a:r>
-                      <a:endParaRPr lang="en-US" sz="1100" dirty="0">
-                        <a:latin typeface="Calibri" charset="0"/>
-                        <a:ea typeface="Calibri" charset="0"/>
-                        <a:cs typeface="Calibri" charset="0"/>
-                      </a:endParaRPr>
-                    </a:p>
-                  </a:txBody>
-                  <a:tcPr marL="91440" marR="91440" marT="45720" marB="45720" anchor="ctr">
-                    <a:lnL w="0" cap="flat" cmpd="sng" algn="ctr">
-                      <a:noFill/>
-                    </a:lnL>
-                    <a:lnR w="0" cap="flat" cmpd="sng" algn="ctr">
-                      <a:noFill/>
-                    </a:lnR>
-                    <a:lnT w="0" cap="flat" cmpd="sng" algn="ctr">
-                      <a:noFill/>
-                    </a:lnT>
-                    <a:lnB w="0" cap="flat" cmpd="sng" algn="ctr">
-                      <a:noFill/>
-                    </a:lnB>
-                    <a:solidFill>
-                      <a:srgbClr val="EEF3F6"/>
-                    </a:solidFill>
-                  </a:tcPr>
-                </a:tc>
-                <a:tc>
-                  <a:txBody>
-                    <a:bodyPr/>
-                    <a:lstStyle/>
-                    <a:p>
-                      <a:pPr algn="ctr" indent="0" marL="0">
-                        <a:buNone/>
-                      </a:pPr>
-                      <a:r>
-                        <a:rPr lang="en-US" sz="1100" dirty="0">
-                          <a:solidFill>
-                            <a:srgbClr val="1B2A4A"/>
-                          </a:solidFill>
-                          <a:latin typeface="Calibri" pitchFamily="34" charset="0"/>
-                          <a:ea typeface="Calibri" pitchFamily="34" charset="-122"/>
-                          <a:cs typeface="Calibri" pitchFamily="34" charset="-120"/>
-                        </a:rPr>
-                        <a:t>Fit OK</a:t>
-                      </a:r>
-                      <a:endParaRPr lang="en-US" sz="1100" dirty="0">
-                        <a:latin typeface="Calibri" charset="0"/>
-                        <a:ea typeface="Calibri" charset="0"/>
-                        <a:cs typeface="Calibri" charset="0"/>
-                      </a:endParaRPr>
-                    </a:p>
-                  </a:txBody>
-                  <a:tcPr marL="91440" marR="91440" marT="45720" marB="45720" anchor="ctr">
-                    <a:lnL w="0" cap="flat" cmpd="sng" algn="ctr">
-                      <a:noFill/>
-                    </a:lnL>
-                    <a:lnR w="0" cap="flat" cmpd="sng" algn="ctr">
-                      <a:noFill/>
-                    </a:lnR>
-                    <a:lnT w="0" cap="flat" cmpd="sng" algn="ctr">
-                      <a:noFill/>
-                    </a:lnT>
-                    <a:lnB w="0" cap="flat" cmpd="sng" algn="ctr">
-                      <a:noFill/>
-                    </a:lnB>
-                    <a:solidFill>
-                      <a:srgbClr val="EEF3F6"/>
-                    </a:solidFill>
-                  </a:tcPr>
-                </a:tc>
-              </a:tr>
-              <a:tr h="329184">
-                <a:tc>
-                  <a:txBody>
-                    <a:bodyPr/>
-                    <a:lstStyle/>
-                    <a:p>
-                      <a:pPr algn="ctr" indent="0" marL="0">
-                        <a:buNone/>
-                      </a:pPr>
-                      <a:r>
-                        <a:rPr lang="en-US" sz="1100" dirty="0">
-                          <a:solidFill>
-                            <a:srgbClr val="1B2A4A"/>
-                          </a:solidFill>
-                          <a:latin typeface="Calibri" pitchFamily="34" charset="0"/>
-                          <a:ea typeface="Calibri" pitchFamily="34" charset="-122"/>
-                          <a:cs typeface="Calibri" pitchFamily="34" charset="-120"/>
-                        </a:rPr>
-                        <a:t>14:15-14:30</a:t>
-                      </a:r>
-                      <a:endParaRPr lang="en-US" sz="1100" dirty="0">
-                        <a:latin typeface="Calibri" charset="0"/>
-                        <a:ea typeface="Calibri" charset="0"/>
-                        <a:cs typeface="Calibri" charset="0"/>
-                      </a:endParaRPr>
-                    </a:p>
-                  </a:txBody>
-                  <a:tcPr marL="91440" marR="91440" marT="45720" marB="45720" anchor="ctr">
-                    <a:lnL w="0" cap="flat" cmpd="sng" algn="ctr">
-                      <a:noFill/>
-                    </a:lnL>
-                    <a:lnR w="0" cap="flat" cmpd="sng" algn="ctr">
-                      <a:noFill/>
-                    </a:lnR>
-                    <a:lnT w="0" cap="flat" cmpd="sng" algn="ctr">
-                      <a:noFill/>
-                    </a:lnT>
-                    <a:lnB w="0" cap="flat" cmpd="sng" algn="ctr">
-                      <a:noFill/>
-                    </a:lnB>
-                    <a:solidFill>
-                      <a:srgbClr val="FFFFFF"/>
-                    </a:solidFill>
-                  </a:tcPr>
-                </a:tc>
-                <a:tc>
-                  <a:txBody>
-                    <a:bodyPr/>
-                    <a:lstStyle/>
-                    <a:p>
-                      <a:pPr algn="ctr" indent="0" marL="0">
-                        <a:buNone/>
-                      </a:pPr>
-                      <a:r>
-                        <a:rPr lang="en-US" sz="1100" dirty="0">
-                          <a:solidFill>
-                            <a:srgbClr val="1B2A4A"/>
-                          </a:solidFill>
-                          <a:latin typeface="Calibri" pitchFamily="34" charset="0"/>
-                          <a:ea typeface="Calibri" pitchFamily="34" charset="-122"/>
-                          <a:cs typeface="Calibri" pitchFamily="34" charset="-120"/>
-                        </a:rPr>
-                        <a:t>16.33</a:t>
-                      </a:r>
-                      <a:endParaRPr lang="en-US" sz="1100" dirty="0">
-                        <a:latin typeface="Calibri" charset="0"/>
-                        <a:ea typeface="Calibri" charset="0"/>
-                        <a:cs typeface="Calibri" charset="0"/>
-                      </a:endParaRPr>
-                    </a:p>
-                  </a:txBody>
-                  <a:tcPr marL="91440" marR="91440" marT="45720" marB="45720" anchor="ctr">
-                    <a:lnL w="0" cap="flat" cmpd="sng" algn="ctr">
-                      <a:noFill/>
-                    </a:lnL>
-                    <a:lnR w="0" cap="flat" cmpd="sng" algn="ctr">
-                      <a:noFill/>
-                    </a:lnR>
-                    <a:lnT w="0" cap="flat" cmpd="sng" algn="ctr">
-                      <a:noFill/>
-                    </a:lnT>
-                    <a:lnB w="0" cap="flat" cmpd="sng" algn="ctr">
-                      <a:noFill/>
-                    </a:lnB>
-                    <a:solidFill>
-                      <a:srgbClr val="FFFFFF"/>
-                    </a:solidFill>
-                  </a:tcPr>
-                </a:tc>
-                <a:tc>
-                  <a:txBody>
-                    <a:bodyPr/>
-                    <a:lstStyle/>
-                    <a:p>
-                      <a:pPr algn="ctr" indent="0" marL="0">
-                        <a:buNone/>
-                      </a:pPr>
-                      <a:r>
-                        <a:rPr lang="en-US" sz="1100" dirty="0">
-                          <a:solidFill>
-                            <a:srgbClr val="1B2A4A"/>
-                          </a:solidFill>
-                          <a:latin typeface="Calibri" pitchFamily="34" charset="0"/>
-                          <a:ea typeface="Calibri" pitchFamily="34" charset="-122"/>
-                          <a:cs typeface="Calibri" pitchFamily="34" charset="-120"/>
-                        </a:rPr>
-                        <a:t>1.24</a:t>
-                      </a:r>
-                      <a:endParaRPr lang="en-US" sz="1100" dirty="0">
-                        <a:latin typeface="Calibri" charset="0"/>
-                        <a:ea typeface="Calibri" charset="0"/>
-                        <a:cs typeface="Calibri" charset="0"/>
-                      </a:endParaRPr>
-                    </a:p>
-                  </a:txBody>
-                  <a:tcPr marL="91440" marR="91440" marT="45720" marB="45720" anchor="ctr">
-                    <a:lnL w="0" cap="flat" cmpd="sng" algn="ctr">
-                      <a:noFill/>
-                    </a:lnL>
-                    <a:lnR w="0" cap="flat" cmpd="sng" algn="ctr">
-                      <a:noFill/>
-                    </a:lnR>
-                    <a:lnT w="0" cap="flat" cmpd="sng" algn="ctr">
-                      <a:noFill/>
-                    </a:lnT>
-                    <a:lnB w="0" cap="flat" cmpd="sng" algn="ctr">
-                      <a:noFill/>
-                    </a:lnB>
-                    <a:solidFill>
-                      <a:srgbClr val="FFFFFF"/>
-                    </a:solidFill>
-                  </a:tcPr>
-                </a:tc>
-                <a:tc>
-                  <a:txBody>
-                    <a:bodyPr/>
-                    <a:lstStyle/>
-                    <a:p>
-                      <a:pPr algn="ctr" indent="0" marL="0">
-                        <a:buNone/>
-                      </a:pPr>
-                      <a:r>
-                        <a:rPr lang="en-US" sz="1100" dirty="0">
-                          <a:solidFill>
-                            <a:srgbClr val="1B2A4A"/>
-                          </a:solidFill>
-                          <a:latin typeface="Calibri" pitchFamily="34" charset="0"/>
-                          <a:ea typeface="Calibri" pitchFamily="34" charset="-122"/>
-                          <a:cs typeface="Calibri" pitchFamily="34" charset="-120"/>
-                        </a:rPr>
-                        <a:t>0.257</a:t>
-                      </a:r>
-                      <a:endParaRPr lang="en-US" sz="1100" dirty="0">
-                        <a:latin typeface="Calibri" charset="0"/>
-                        <a:ea typeface="Calibri" charset="0"/>
-                        <a:cs typeface="Calibri" charset="0"/>
-                      </a:endParaRPr>
-                    </a:p>
-                  </a:txBody>
-                  <a:tcPr marL="91440" marR="91440" marT="45720" marB="45720" anchor="ctr">
-                    <a:lnL w="0" cap="flat" cmpd="sng" algn="ctr">
-                      <a:noFill/>
-                    </a:lnL>
-                    <a:lnR w="0" cap="flat" cmpd="sng" algn="ctr">
-                      <a:noFill/>
-                    </a:lnR>
-                    <a:lnT w="0" cap="flat" cmpd="sng" algn="ctr">
-                      <a:noFill/>
-                    </a:lnT>
-                    <a:lnB w="0" cap="flat" cmpd="sng" algn="ctr">
-                      <a:noFill/>
-                    </a:lnB>
-                    <a:solidFill>
-                      <a:srgbClr val="FFFFFF"/>
-                    </a:solidFill>
-                  </a:tcPr>
-                </a:tc>
-                <a:tc>
-                  <a:txBody>
-                    <a:bodyPr/>
-                    <a:lstStyle/>
-                    <a:p>
-                      <a:pPr algn="ctr" indent="0" marL="0">
-                        <a:buNone/>
-                      </a:pPr>
-                      <a:r>
-                        <a:rPr lang="en-US" sz="1100" dirty="0">
-                          <a:solidFill>
-                            <a:srgbClr val="1B2A4A"/>
-                          </a:solidFill>
-                          <a:latin typeface="Calibri" pitchFamily="34" charset="0"/>
-                          <a:ea typeface="Calibri" pitchFamily="34" charset="-122"/>
-                          <a:cs typeface="Calibri" pitchFamily="34" charset="-120"/>
-                        </a:rPr>
-                        <a:t>Fit OK</a:t>
-                      </a:r>
-                      <a:endParaRPr lang="en-US" sz="1100" dirty="0">
-                        <a:latin typeface="Calibri" charset="0"/>
-                        <a:ea typeface="Calibri" charset="0"/>
-                        <a:cs typeface="Calibri" charset="0"/>
-                      </a:endParaRPr>
-                    </a:p>
-                  </a:txBody>
-                  <a:tcPr marL="91440" marR="91440" marT="45720" marB="45720" anchor="ctr">
-                    <a:lnL w="0" cap="flat" cmpd="sng" algn="ctr">
-                      <a:noFill/>
-                    </a:lnL>
-                    <a:lnR w="0" cap="flat" cmpd="sng" algn="ctr">
-                      <a:noFill/>
-                    </a:lnR>
-                    <a:lnT w="0" cap="flat" cmpd="sng" algn="ctr">
-                      <a:noFill/>
-                    </a:lnT>
-                    <a:lnB w="0" cap="flat" cmpd="sng" algn="ctr">
-                      <a:noFill/>
-                    </a:lnB>
-                    <a:solidFill>
-                      <a:srgbClr val="FFFFFF"/>
-                    </a:solidFill>
-                  </a:tcPr>
-                </a:tc>
-              </a:tr>
             </a:tbl>
           </a:graphicData>
         </a:graphic>
@@ -19441,7 +18010,7 @@
                 <a:ea typeface="Cambria" pitchFamily="34" charset="-122"/>
                 <a:cs typeface="Cambria" pitchFamily="34" charset="-120"/>
               </a:rPr>
-              <a:t>0 of 8</a:t>
+              <a:t>0 of 3</a:t>
             </a:r>
             <a:endParaRPr lang="en-US" sz="3200" dirty="0"/>
           </a:p>
@@ -19477,7 +18046,7 @@
                   <a:schemeClr val="tx1"/>
                 </a:solidFill>
               </a:rPr>
-              <a:t>slots reject Poisson at α = 0.05 (0.4 expected by chance)</a:t>
+              <a:t>slots reject Poisson at α = 0.05 (0.15 expected by chance)</a:t>
             </a:r>
             <a:endParaRPr lang="en-US" sz="1200" dirty="0"/>
           </a:p>
@@ -19516,7 +18085,7 @@
                 <a:ea typeface="Cambria" pitchFamily="34" charset="-122"/>
                 <a:cs typeface="Cambria" pitchFamily="34" charset="-120"/>
               </a:rPr>
-              <a:t>≈ 1</a:t>
+              <a:t>0.84–1.25</a:t>
             </a:r>
             <a:endParaRPr lang="en-US" sz="3200" dirty="0"/>
           </a:p>
@@ -19552,7 +18121,7 @@
                   <a:schemeClr val="tx1"/>
                 </a:solidFill>
               </a:rPr>
-              <a:t>variance-to-mean ratio, as Poisson requires</a:t>
+              <a:t>variance-to-mean ratio, close to 1 as Poisson requires</a:t>
             </a:r>
             <a:endParaRPr lang="en-US" sz="1200" dirty="0"/>
           </a:p>

</xml_diff>